<commit_message>
Replace CiS-Projekt.pptx mit Besehenden Teil der  Controlteil
</commit_message>
<xml_diff>
--- a/CiS-Projekt.pptx
+++ b/CiS-Projekt.pptx
@@ -6,10 +6,10 @@
     <p:sldMasterId id="2147483661" r:id="rId2"/>
   </p:sldMasterIdLst>
   <p:notesMasterIdLst>
-    <p:notesMasterId r:id="rId10"/>
+    <p:notesMasterId r:id="rId16"/>
   </p:notesMasterIdLst>
   <p:handoutMasterIdLst>
-    <p:handoutMasterId r:id="rId11"/>
+    <p:handoutMasterId r:id="rId17"/>
   </p:handoutMasterIdLst>
   <p:sldIdLst>
     <p:sldId id="256" r:id="rId3"/>
@@ -18,7 +18,13 @@
     <p:sldId id="259" r:id="rId6"/>
     <p:sldId id="260" r:id="rId7"/>
     <p:sldId id="261" r:id="rId8"/>
-    <p:sldId id="262" r:id="rId9"/>
+    <p:sldId id="263" r:id="rId9"/>
+    <p:sldId id="264" r:id="rId10"/>
+    <p:sldId id="265" r:id="rId11"/>
+    <p:sldId id="266" r:id="rId12"/>
+    <p:sldId id="267" r:id="rId13"/>
+    <p:sldId id="268" r:id="rId14"/>
+    <p:sldId id="262" r:id="rId15"/>
   </p:sldIdLst>
   <p:sldSz cx="9144000" cy="6858000" type="screen4x3"/>
   <p:notesSz cx="7772400" cy="10058400"/>
@@ -117,6 +123,14 @@
       </a:defRPr>
     </a:lvl9pPr>
   </p:defaultTextStyle>
+  <p:extLst>
+    <p:ext uri="{EFAFB233-063F-42B5-8137-9DF3F51BA10A}">
+      <p15:sldGuideLst xmlns:p15="http://schemas.microsoft.com/office/powerpoint/2012/main"/>
+    </p:ext>
+    <p:ext uri="{2D200454-40CA-4A62-9FC3-DE9A4176ACB9}">
+      <p15:notesGuideLst xmlns:p15="http://schemas.microsoft.com/office/powerpoint/2012/main"/>
+    </p:ext>
+  </p:extLst>
 </p:presentation>
 </file>
 
@@ -214,7 +228,7 @@
           <a:p>
             <a:fld id="{77AB800C-305E-2C41-8096-0EDBE764B1AF}" type="datetimeFigureOut">
               <a:rPr lang="en-DE" smtClean="0"/>
-              <a:t>16.10.24</a:t>
+              <a:t>10/21/2024</a:t>
             </a:fld>
             <a:endParaRPr lang="en-DE"/>
           </a:p>
@@ -292,7 +306,7 @@
           <a:p>
             <a:fld id="{D4D7E029-301A-A64B-8B81-DB73CD4A0836}" type="slidenum">
               <a:rPr lang="en-DE" smtClean="0"/>
-              <a:t>‹#›</a:t>
+              <a:t>‹Nr.›</a:t>
             </a:fld>
             <a:endParaRPr lang="en-DE"/>
           </a:p>
@@ -391,7 +405,7 @@
           <a:p>
             <a:fld id="{502A31B7-B52A-AE43-A408-51D438091011}" type="datetimeFigureOut">
               <a:rPr lang="en-DE" smtClean="0"/>
-              <a:t>16.10.24</a:t>
+              <a:t>10/21/2024</a:t>
             </a:fld>
             <a:endParaRPr lang="en-DE"/>
           </a:p>
@@ -550,7 +564,7 @@
           <a:p>
             <a:fld id="{F9D91CA9-4EA3-AF47-8B3F-ADB35F2089EB}" type="slidenum">
               <a:rPr lang="en-DE" smtClean="0"/>
-              <a:t>‹#›</a:t>
+              <a:t>‹Nr.›</a:t>
             </a:fld>
             <a:endParaRPr lang="en-DE"/>
           </a:p>
@@ -699,7 +713,7 @@
           <a:p>
             <a:fld id="{87EC9D13-9386-5F42-819D-64F68B7EC33E}" type="datetime1">
               <a:rPr lang="de-DE" smtClean="0"/>
-              <a:t>16.10.24</a:t>
+              <a:t>21.10.2024</a:t>
             </a:fld>
             <a:endParaRPr lang="en-DE"/>
           </a:p>
@@ -753,7 +767,7 @@
           <a:p>
             <a:fld id="{A800C47E-6ED7-0A43-8B18-8C65B1973209}" type="slidenum">
               <a:rPr lang="en-DE" smtClean="0"/>
-              <a:t>‹#›</a:t>
+              <a:t>‹Nr.›</a:t>
             </a:fld>
             <a:endParaRPr lang="en-DE"/>
           </a:p>
@@ -924,7 +938,7 @@
           <a:p>
             <a:fld id="{527A4C91-0AAD-D347-8A12-A61F0BD423D4}" type="datetime1">
               <a:rPr lang="de-DE" smtClean="0"/>
-              <a:t>16.10.24</a:t>
+              <a:t>21.10.2024</a:t>
             </a:fld>
             <a:endParaRPr lang="en-DE"/>
           </a:p>
@@ -978,7 +992,7 @@
           <a:p>
             <a:fld id="{A800C47E-6ED7-0A43-8B18-8C65B1973209}" type="slidenum">
               <a:rPr lang="en-DE" smtClean="0"/>
-              <a:t>‹#›</a:t>
+              <a:t>‹Nr.›</a:t>
             </a:fld>
             <a:endParaRPr lang="en-DE"/>
           </a:p>
@@ -1225,7 +1239,7 @@
           <a:p>
             <a:fld id="{4522998C-E1D0-3948-9C4C-A4844208B326}" type="datetime1">
               <a:rPr lang="de-DE" smtClean="0"/>
-              <a:t>16.10.24</a:t>
+              <a:t>21.10.2024</a:t>
             </a:fld>
             <a:endParaRPr lang="en-DE"/>
           </a:p>
@@ -1279,7 +1293,7 @@
           <a:p>
             <a:fld id="{A800C47E-6ED7-0A43-8B18-8C65B1973209}" type="slidenum">
               <a:rPr lang="en-DE" smtClean="0"/>
-              <a:t>‹#›</a:t>
+              <a:t>‹Nr.›</a:t>
             </a:fld>
             <a:endParaRPr lang="en-DE"/>
           </a:p>
@@ -1602,7 +1616,7 @@
           <a:p>
             <a:fld id="{44DC767A-87D7-8847-8135-03DC509387E7}" type="datetime1">
               <a:rPr lang="de-DE" smtClean="0"/>
-              <a:t>16.10.24</a:t>
+              <a:t>21.10.2024</a:t>
             </a:fld>
             <a:endParaRPr lang="en-DE"/>
           </a:p>
@@ -1656,7 +1670,7 @@
           <a:p>
             <a:fld id="{A800C47E-6ED7-0A43-8B18-8C65B1973209}" type="slidenum">
               <a:rPr lang="en-DE" smtClean="0"/>
-              <a:t>‹#›</a:t>
+              <a:t>‹Nr.›</a:t>
             </a:fld>
             <a:endParaRPr lang="en-DE"/>
           </a:p>
@@ -1710,7 +1724,7 @@
           <a:p>
             <a:fld id="{EA779ABD-E509-A24E-B468-A7395207E925}" type="datetime1">
               <a:rPr lang="de-DE" smtClean="0"/>
-              <a:t>16.10.24</a:t>
+              <a:t>21.10.2024</a:t>
             </a:fld>
             <a:endParaRPr lang="en-DE" dirty="0"/>
           </a:p>
@@ -1764,7 +1778,7 @@
           <a:p>
             <a:fld id="{1148E9C0-692D-B340-AF6F-432654B065A1}" type="slidenum">
               <a:rPr lang="en-DE" smtClean="0"/>
-              <a:t>‹#›</a:t>
+              <a:t>‹Nr.›</a:t>
             </a:fld>
             <a:endParaRPr lang="en-DE" dirty="0"/>
           </a:p>
@@ -1900,7 +1914,7 @@
           <a:p>
             <a:fld id="{12798F19-8D51-794B-8ACF-FCEE93C20526}" type="datetime1">
               <a:rPr lang="de-DE" smtClean="0"/>
-              <a:t>16.10.24</a:t>
+              <a:t>21.10.2024</a:t>
             </a:fld>
             <a:endParaRPr lang="en-DE"/>
           </a:p>
@@ -1954,7 +1968,7 @@
           <a:p>
             <a:fld id="{1148E9C0-692D-B340-AF6F-432654B065A1}" type="slidenum">
               <a:rPr lang="en-DE" smtClean="0"/>
-              <a:t>‹#›</a:t>
+              <a:t>‹Nr.›</a:t>
             </a:fld>
             <a:endParaRPr lang="en-DE"/>
           </a:p>
@@ -2087,7 +2101,7 @@
           <a:p>
             <a:fld id="{5E82FD34-7F6C-EC46-AEB1-845633BA5368}" type="datetime1">
               <a:rPr lang="de-DE" smtClean="0"/>
-              <a:t>16.10.24</a:t>
+              <a:t>21.10.2024</a:t>
             </a:fld>
             <a:endParaRPr lang="en-DE"/>
           </a:p>
@@ -2141,7 +2155,7 @@
           <a:p>
             <a:fld id="{1148E9C0-692D-B340-AF6F-432654B065A1}" type="slidenum">
               <a:rPr lang="en-DE" smtClean="0"/>
-              <a:t>‹#›</a:t>
+              <a:t>‹Nr.›</a:t>
             </a:fld>
             <a:endParaRPr lang="en-DE"/>
           </a:p>
@@ -2312,7 +2326,7 @@
           <a:p>
             <a:fld id="{CB9D10AC-CF20-B944-9D9D-D70D31AC71E3}" type="datetime1">
               <a:rPr lang="de-DE" smtClean="0"/>
-              <a:t>16.10.24</a:t>
+              <a:t>21.10.2024</a:t>
             </a:fld>
             <a:endParaRPr lang="en-DE"/>
           </a:p>
@@ -2366,7 +2380,7 @@
           <a:p>
             <a:fld id="{1148E9C0-692D-B340-AF6F-432654B065A1}" type="slidenum">
               <a:rPr lang="en-DE" smtClean="0"/>
-              <a:t>‹#›</a:t>
+              <a:t>‹Nr.›</a:t>
             </a:fld>
             <a:endParaRPr lang="en-DE"/>
           </a:p>
@@ -2461,7 +2475,7 @@
           <a:p>
             <a:fld id="{849E575B-8C89-5A46-A500-EEE867877C68}" type="datetime1">
               <a:rPr lang="de-DE" smtClean="0"/>
-              <a:t>16.10.24</a:t>
+              <a:t>21.10.2024</a:t>
             </a:fld>
             <a:endParaRPr lang="en-DE"/>
           </a:p>
@@ -2515,7 +2529,7 @@
           <a:p>
             <a:fld id="{1148E9C0-692D-B340-AF6F-432654B065A1}" type="slidenum">
               <a:rPr lang="en-DE" smtClean="0"/>
-              <a:t>‹#›</a:t>
+              <a:t>‹Nr.›</a:t>
             </a:fld>
             <a:endParaRPr lang="en-DE"/>
           </a:p>
@@ -2610,7 +2624,7 @@
           <a:p>
             <a:fld id="{74293AA7-5923-6A4D-8C54-7BAA40441436}" type="datetime1">
               <a:rPr lang="de-DE" smtClean="0"/>
-              <a:t>16.10.24</a:t>
+              <a:t>21.10.2024</a:t>
             </a:fld>
             <a:endParaRPr lang="en-DE"/>
           </a:p>
@@ -2664,7 +2678,7 @@
           <a:p>
             <a:fld id="{1148E9C0-692D-B340-AF6F-432654B065A1}" type="slidenum">
               <a:rPr lang="en-DE" smtClean="0"/>
-              <a:t>‹#›</a:t>
+              <a:t>‹Nr.›</a:t>
             </a:fld>
             <a:endParaRPr lang="en-DE"/>
           </a:p>
@@ -2873,7 +2887,7 @@
           <a:p>
             <a:fld id="{BB4820AA-6151-0C4C-B826-4FC62DBABCAE}" type="datetime1">
               <a:rPr lang="de-DE" smtClean="0"/>
-              <a:t>16.10.24</a:t>
+              <a:t>21.10.2024</a:t>
             </a:fld>
             <a:endParaRPr lang="en-DE"/>
           </a:p>
@@ -2927,7 +2941,7 @@
           <a:p>
             <a:fld id="{1148E9C0-692D-B340-AF6F-432654B065A1}" type="slidenum">
               <a:rPr lang="en-DE" smtClean="0"/>
-              <a:t>‹#›</a:t>
+              <a:t>‹Nr.›</a:t>
             </a:fld>
             <a:endParaRPr lang="en-DE"/>
           </a:p>
@@ -3063,7 +3077,7 @@
           <a:p>
             <a:fld id="{8FB64747-FE93-C348-B38C-977650B50862}" type="datetime1">
               <a:rPr lang="de-DE" smtClean="0"/>
-              <a:t>16.10.24</a:t>
+              <a:t>21.10.2024</a:t>
             </a:fld>
             <a:endParaRPr lang="en-DE"/>
           </a:p>
@@ -3117,7 +3131,7 @@
           <a:p>
             <a:fld id="{A800C47E-6ED7-0A43-8B18-8C65B1973209}" type="slidenum">
               <a:rPr lang="en-DE" smtClean="0"/>
-              <a:t>‹#›</a:t>
+              <a:t>‹Nr.›</a:t>
             </a:fld>
             <a:endParaRPr lang="en-DE"/>
           </a:p>
@@ -3326,7 +3340,7 @@
           <a:p>
             <a:fld id="{64004B49-DE67-A942-A928-C596320198E2}" type="datetime1">
               <a:rPr lang="de-DE" smtClean="0"/>
-              <a:t>16.10.24</a:t>
+              <a:t>21.10.2024</a:t>
             </a:fld>
             <a:endParaRPr lang="en-DE"/>
           </a:p>
@@ -3380,7 +3394,7 @@
           <a:p>
             <a:fld id="{1148E9C0-692D-B340-AF6F-432654B065A1}" type="slidenum">
               <a:rPr lang="en-DE" smtClean="0"/>
-              <a:t>‹#›</a:t>
+              <a:t>‹Nr.›</a:t>
             </a:fld>
             <a:endParaRPr lang="en-DE"/>
           </a:p>
@@ -3589,7 +3603,7 @@
           <a:p>
             <a:fld id="{C7C9E177-A04B-2144-839B-78BA09DD5A4B}" type="datetime1">
               <a:rPr lang="de-DE" smtClean="0"/>
-              <a:t>16.10.24</a:t>
+              <a:t>21.10.2024</a:t>
             </a:fld>
             <a:endParaRPr lang="en-DE"/>
           </a:p>
@@ -3643,7 +3657,7 @@
           <a:p>
             <a:fld id="{1148E9C0-692D-B340-AF6F-432654B065A1}" type="slidenum">
               <a:rPr lang="en-DE" smtClean="0"/>
-              <a:t>‹#›</a:t>
+              <a:t>‹Nr.›</a:t>
             </a:fld>
             <a:endParaRPr lang="en-DE"/>
           </a:p>
@@ -3814,7 +3828,7 @@
           <a:p>
             <a:fld id="{4989E16C-ECE5-A24A-BE33-2A36DC0B5546}" type="datetime1">
               <a:rPr lang="de-DE" smtClean="0"/>
-              <a:t>16.10.24</a:t>
+              <a:t>21.10.2024</a:t>
             </a:fld>
             <a:endParaRPr lang="en-DE"/>
           </a:p>
@@ -3868,7 +3882,7 @@
           <a:p>
             <a:fld id="{1148E9C0-692D-B340-AF6F-432654B065A1}" type="slidenum">
               <a:rPr lang="en-DE" smtClean="0"/>
-              <a:t>‹#›</a:t>
+              <a:t>‹Nr.›</a:t>
             </a:fld>
             <a:endParaRPr lang="en-DE"/>
           </a:p>
@@ -4115,7 +4129,7 @@
           <a:p>
             <a:fld id="{3513ED3D-829E-C84D-A902-4B819A54677D}" type="datetime1">
               <a:rPr lang="de-DE" smtClean="0"/>
-              <a:t>16.10.24</a:t>
+              <a:t>21.10.2024</a:t>
             </a:fld>
             <a:endParaRPr lang="en-DE"/>
           </a:p>
@@ -4169,7 +4183,7 @@
           <a:p>
             <a:fld id="{1148E9C0-692D-B340-AF6F-432654B065A1}" type="slidenum">
               <a:rPr lang="en-DE" smtClean="0"/>
-              <a:t>‹#›</a:t>
+              <a:t>‹Nr.›</a:t>
             </a:fld>
             <a:endParaRPr lang="en-DE"/>
           </a:p>
@@ -4492,7 +4506,7 @@
           <a:p>
             <a:fld id="{3212F563-1640-9541-9315-7D892C0CA96C}" type="datetime1">
               <a:rPr lang="de-DE" smtClean="0"/>
-              <a:t>16.10.24</a:t>
+              <a:t>21.10.2024</a:t>
             </a:fld>
             <a:endParaRPr lang="en-DE"/>
           </a:p>
@@ -4546,7 +4560,7 @@
           <a:p>
             <a:fld id="{1148E9C0-692D-B340-AF6F-432654B065A1}" type="slidenum">
               <a:rPr lang="en-DE" smtClean="0"/>
-              <a:t>‹#›</a:t>
+              <a:t>‹Nr.›</a:t>
             </a:fld>
             <a:endParaRPr lang="en-DE"/>
           </a:p>
@@ -4679,7 +4693,7 @@
           <a:p>
             <a:fld id="{3AA625C0-B810-4042-A60B-CD0C68D4A602}" type="datetime1">
               <a:rPr lang="de-DE" smtClean="0"/>
-              <a:t>16.10.24</a:t>
+              <a:t>21.10.2024</a:t>
             </a:fld>
             <a:endParaRPr lang="en-DE"/>
           </a:p>
@@ -4733,7 +4747,7 @@
           <a:p>
             <a:fld id="{A800C47E-6ED7-0A43-8B18-8C65B1973209}" type="slidenum">
               <a:rPr lang="en-DE" smtClean="0"/>
-              <a:t>‹#›</a:t>
+              <a:t>‹Nr.›</a:t>
             </a:fld>
             <a:endParaRPr lang="en-DE"/>
           </a:p>
@@ -4904,7 +4918,7 @@
           <a:p>
             <a:fld id="{459B706D-46CB-4945-98A8-83DD4363C0CC}" type="datetime1">
               <a:rPr lang="de-DE" smtClean="0"/>
-              <a:t>16.10.24</a:t>
+              <a:t>21.10.2024</a:t>
             </a:fld>
             <a:endParaRPr lang="en-DE"/>
           </a:p>
@@ -4958,7 +4972,7 @@
           <a:p>
             <a:fld id="{A800C47E-6ED7-0A43-8B18-8C65B1973209}" type="slidenum">
               <a:rPr lang="en-DE" smtClean="0"/>
-              <a:t>‹#›</a:t>
+              <a:t>‹Nr.›</a:t>
             </a:fld>
             <a:endParaRPr lang="en-DE"/>
           </a:p>
@@ -5053,7 +5067,7 @@
           <a:p>
             <a:fld id="{453998D7-97AC-4645-9850-2BABD1A4FF50}" type="datetime1">
               <a:rPr lang="de-DE" smtClean="0"/>
-              <a:t>16.10.24</a:t>
+              <a:t>21.10.2024</a:t>
             </a:fld>
             <a:endParaRPr lang="en-DE"/>
           </a:p>
@@ -5107,7 +5121,7 @@
           <a:p>
             <a:fld id="{A800C47E-6ED7-0A43-8B18-8C65B1973209}" type="slidenum">
               <a:rPr lang="en-DE" smtClean="0"/>
-              <a:t>‹#›</a:t>
+              <a:t>‹Nr.›</a:t>
             </a:fld>
             <a:endParaRPr lang="en-DE"/>
           </a:p>
@@ -5202,7 +5216,7 @@
           <a:p>
             <a:fld id="{16ADEC65-F8A2-6743-8A16-0664123CA582}" type="datetime1">
               <a:rPr lang="de-DE" smtClean="0"/>
-              <a:t>16.10.24</a:t>
+              <a:t>21.10.2024</a:t>
             </a:fld>
             <a:endParaRPr lang="en-DE"/>
           </a:p>
@@ -5256,7 +5270,7 @@
           <a:p>
             <a:fld id="{A800C47E-6ED7-0A43-8B18-8C65B1973209}" type="slidenum">
               <a:rPr lang="en-DE" smtClean="0"/>
-              <a:t>‹#›</a:t>
+              <a:t>‹Nr.›</a:t>
             </a:fld>
             <a:endParaRPr lang="en-DE"/>
           </a:p>
@@ -5465,7 +5479,7 @@
           <a:p>
             <a:fld id="{CEF5A2FE-F587-8945-B5BB-F8F2B9389C3F}" type="datetime1">
               <a:rPr lang="de-DE" smtClean="0"/>
-              <a:t>16.10.24</a:t>
+              <a:t>21.10.2024</a:t>
             </a:fld>
             <a:endParaRPr lang="en-DE"/>
           </a:p>
@@ -5519,7 +5533,7 @@
           <a:p>
             <a:fld id="{A800C47E-6ED7-0A43-8B18-8C65B1973209}" type="slidenum">
               <a:rPr lang="en-DE" smtClean="0"/>
-              <a:t>‹#›</a:t>
+              <a:t>‹Nr.›</a:t>
             </a:fld>
             <a:endParaRPr lang="en-DE"/>
           </a:p>
@@ -5728,7 +5742,7 @@
           <a:p>
             <a:fld id="{A79FFF01-31BB-1349-904F-CC2DBF738C7D}" type="datetime1">
               <a:rPr lang="de-DE" smtClean="0"/>
-              <a:t>16.10.24</a:t>
+              <a:t>21.10.2024</a:t>
             </a:fld>
             <a:endParaRPr lang="en-DE"/>
           </a:p>
@@ -5782,7 +5796,7 @@
           <a:p>
             <a:fld id="{A800C47E-6ED7-0A43-8B18-8C65B1973209}" type="slidenum">
               <a:rPr lang="en-DE" smtClean="0"/>
-              <a:t>‹#›</a:t>
+              <a:t>‹Nr.›</a:t>
             </a:fld>
             <a:endParaRPr lang="en-DE"/>
           </a:p>
@@ -5991,7 +6005,7 @@
           <a:p>
             <a:fld id="{A671271C-13EF-A14D-AEBE-C2523EB58D17}" type="datetime1">
               <a:rPr lang="de-DE" smtClean="0"/>
-              <a:t>16.10.24</a:t>
+              <a:t>21.10.2024</a:t>
             </a:fld>
             <a:endParaRPr lang="en-DE"/>
           </a:p>
@@ -6045,7 +6059,7 @@
           <a:p>
             <a:fld id="{A800C47E-6ED7-0A43-8B18-8C65B1973209}" type="slidenum">
               <a:rPr lang="en-DE" smtClean="0"/>
-              <a:t>‹#›</a:t>
+              <a:t>‹Nr.›</a:t>
             </a:fld>
             <a:endParaRPr lang="en-DE"/>
           </a:p>
@@ -6920,7 +6934,7 @@
           <a:p>
             <a:fld id="{3787732F-142C-AC47-B643-19D1499432B7}" type="datetime1">
               <a:rPr lang="de-DE" smtClean="0"/>
-              <a:t>16.10.24</a:t>
+              <a:t>21.10.2024</a:t>
             </a:fld>
             <a:endParaRPr lang="en-DE"/>
           </a:p>
@@ -6967,7 +6981,7 @@
           <a:p>
             <a:fld id="{A800C47E-6ED7-0A43-8B18-8C65B1973209}" type="slidenum">
               <a:rPr lang="en-DE" smtClean="0"/>
-              <a:t>‹#›</a:t>
+              <a:t>‹Nr.›</a:t>
             </a:fld>
             <a:endParaRPr lang="en-DE"/>
           </a:p>
@@ -7930,7 +7944,7 @@
           <a:p>
             <a:fld id="{1148E9C0-692D-B340-AF6F-432654B065A1}" type="slidenum">
               <a:rPr lang="en-DE" smtClean="0"/>
-              <a:t>‹#›</a:t>
+              <a:t>‹Nr.›</a:t>
             </a:fld>
             <a:endParaRPr lang="en-DE"/>
           </a:p>
@@ -7977,7 +7991,7 @@
           <a:p>
             <a:fld id="{DEA6639B-6ECB-1F4C-A239-3D3843A9EA7B}" type="datetime1">
               <a:rPr lang="de-DE" smtClean="0"/>
-              <a:t>16.10.24</a:t>
+              <a:t>21.10.2024</a:t>
             </a:fld>
             <a:endParaRPr lang="en-DE"/>
           </a:p>
@@ -8570,6 +8584,810 @@
 </p:sld>
 </file>
 
+<file path=ppt/slides/slide10.xml><?xml version="1.0" encoding="utf-8"?>
+<p:sld xmlns:a="http://schemas.openxmlformats.org/drawingml/2006/main" xmlns:r="http://schemas.openxmlformats.org/officeDocument/2006/relationships" xmlns:p="http://schemas.openxmlformats.org/presentationml/2006/main">
+  <p:cSld>
+    <p:spTree>
+      <p:nvGrpSpPr>
+        <p:cNvPr id="1" name=""/>
+        <p:cNvGrpSpPr/>
+        <p:nvPr/>
+      </p:nvGrpSpPr>
+      <p:grpSpPr>
+        <a:xfrm>
+          <a:off x="0" y="0"/>
+          <a:ext cx="0" cy="0"/>
+          <a:chOff x="0" y="0"/>
+          <a:chExt cx="0" cy="0"/>
+        </a:xfrm>
+      </p:grpSpPr>
+      <p:sp>
+        <p:nvSpPr>
+          <p:cNvPr id="2" name="Titel 1">
+            <a:extLst>
+              <a:ext uri="{FF2B5EF4-FFF2-40B4-BE49-F238E27FC236}">
+                <a16:creationId xmlns:a16="http://schemas.microsoft.com/office/drawing/2014/main" id="{E2282D60-DF05-2EC7-4175-6FB8005C631A}"/>
+              </a:ext>
+            </a:extLst>
+          </p:cNvPr>
+          <p:cNvSpPr>
+            <a:spLocks noGrp="1"/>
+          </p:cNvSpPr>
+          <p:nvPr>
+            <p:ph type="title"/>
+          </p:nvPr>
+        </p:nvSpPr>
+        <p:spPr/>
+        <p:txBody>
+          <a:bodyPr/>
+          <a:lstStyle/>
+          <a:p>
+            <a:r>
+              <a:rPr lang="de-DE" dirty="0"/>
+              <a:t>Welche Software kann man benutzen?</a:t>
+            </a:r>
+          </a:p>
+        </p:txBody>
+      </p:sp>
+      <p:sp>
+        <p:nvSpPr>
+          <p:cNvPr id="3" name="Untertitel 2">
+            <a:extLst>
+              <a:ext uri="{FF2B5EF4-FFF2-40B4-BE49-F238E27FC236}">
+                <a16:creationId xmlns:a16="http://schemas.microsoft.com/office/drawing/2014/main" id="{39E54848-3724-91D2-3B42-F881E4E358C3}"/>
+              </a:ext>
+            </a:extLst>
+          </p:cNvPr>
+          <p:cNvSpPr>
+            <a:spLocks noGrp="1"/>
+          </p:cNvSpPr>
+          <p:nvPr>
+            <p:ph type="subTitle"/>
+          </p:nvPr>
+        </p:nvSpPr>
+        <p:spPr/>
+        <p:txBody>
+          <a:bodyPr/>
+          <a:lstStyle/>
+          <a:p>
+            <a:r>
+              <a:rPr lang="de-DE" dirty="0" err="1"/>
+              <a:t>Pythonroutenplaner</a:t>
+            </a:r>
+            <a:r>
+              <a:rPr lang="de-DE" dirty="0"/>
+              <a:t> bereits implementiert in OSM</a:t>
+            </a:r>
+          </a:p>
+          <a:p>
+            <a:r>
+              <a:rPr lang="de-DE" dirty="0" err="1"/>
+              <a:t>Openrouteservice</a:t>
+            </a:r>
+            <a:endParaRPr lang="de-DE" dirty="0"/>
+          </a:p>
+          <a:p>
+            <a:pPr lvl="1"/>
+            <a:r>
+              <a:rPr lang="de-DE" dirty="0"/>
+              <a:t>Liefert direkt Matrix- und Vektordarstellung</a:t>
+            </a:r>
+          </a:p>
+          <a:p>
+            <a:r>
+              <a:rPr lang="de-DE" dirty="0"/>
+              <a:t>Pyroutelib2</a:t>
+            </a:r>
+          </a:p>
+          <a:p>
+            <a:pPr lvl="1"/>
+            <a:r>
+              <a:rPr lang="de-DE" dirty="0"/>
+              <a:t>Simple Struktur</a:t>
+            </a:r>
+          </a:p>
+          <a:p>
+            <a:pPr lvl="1"/>
+            <a:r>
+              <a:rPr lang="de-DE" dirty="0"/>
+              <a:t>Einfach erweiterbar</a:t>
+            </a:r>
+          </a:p>
+          <a:p>
+            <a:pPr lvl="1"/>
+            <a:r>
+              <a:rPr lang="de-DE" dirty="0"/>
+              <a:t>CSV Output</a:t>
+            </a:r>
+          </a:p>
+        </p:txBody>
+      </p:sp>
+      <p:sp>
+        <p:nvSpPr>
+          <p:cNvPr id="4" name="Datumsplatzhalter 3">
+            <a:extLst>
+              <a:ext uri="{FF2B5EF4-FFF2-40B4-BE49-F238E27FC236}">
+                <a16:creationId xmlns:a16="http://schemas.microsoft.com/office/drawing/2014/main" id="{C89A310E-86E1-D42F-E58D-A7BC2A7819BA}"/>
+              </a:ext>
+            </a:extLst>
+          </p:cNvPr>
+          <p:cNvSpPr>
+            <a:spLocks noGrp="1"/>
+          </p:cNvSpPr>
+          <p:nvPr>
+            <p:ph type="dt" sz="half" idx="10"/>
+          </p:nvPr>
+        </p:nvSpPr>
+        <p:spPr/>
+        <p:txBody>
+          <a:bodyPr/>
+          <a:lstStyle/>
+          <a:p>
+            <a:fld id="{12798F19-8D51-794B-8ACF-FCEE93C20526}" type="datetime1">
+              <a:rPr lang="de-DE" smtClean="0"/>
+              <a:t>21.10.2024</a:t>
+            </a:fld>
+            <a:endParaRPr lang="en-DE"/>
+          </a:p>
+        </p:txBody>
+      </p:sp>
+      <p:sp>
+        <p:nvSpPr>
+          <p:cNvPr id="5" name="Foliennummernplatzhalter 4">
+            <a:extLst>
+              <a:ext uri="{FF2B5EF4-FFF2-40B4-BE49-F238E27FC236}">
+                <a16:creationId xmlns:a16="http://schemas.microsoft.com/office/drawing/2014/main" id="{43247F1F-3C84-FE7E-92CE-1C42B5DA7AB3}"/>
+              </a:ext>
+            </a:extLst>
+          </p:cNvPr>
+          <p:cNvSpPr>
+            <a:spLocks noGrp="1"/>
+          </p:cNvSpPr>
+          <p:nvPr>
+            <p:ph type="sldNum" sz="quarter" idx="12"/>
+          </p:nvPr>
+        </p:nvSpPr>
+        <p:spPr/>
+        <p:txBody>
+          <a:bodyPr/>
+          <a:lstStyle/>
+          <a:p>
+            <a:fld id="{1148E9C0-692D-B340-AF6F-432654B065A1}" type="slidenum">
+              <a:rPr lang="en-DE" smtClean="0"/>
+              <a:t>9</a:t>
+            </a:fld>
+            <a:endParaRPr lang="en-DE"/>
+          </a:p>
+        </p:txBody>
+      </p:sp>
+    </p:spTree>
+    <p:extLst>
+      <p:ext uri="{BB962C8B-B14F-4D97-AF65-F5344CB8AC3E}">
+        <p14:creationId xmlns:p14="http://schemas.microsoft.com/office/powerpoint/2010/main" val="1142652553"/>
+      </p:ext>
+    </p:extLst>
+  </p:cSld>
+  <p:clrMapOvr>
+    <a:masterClrMapping/>
+  </p:clrMapOvr>
+</p:sld>
+</file>
+
+<file path=ppt/slides/slide11.xml><?xml version="1.0" encoding="utf-8"?>
+<p:sld xmlns:a="http://schemas.openxmlformats.org/drawingml/2006/main" xmlns:r="http://schemas.openxmlformats.org/officeDocument/2006/relationships" xmlns:p="http://schemas.openxmlformats.org/presentationml/2006/main">
+  <p:cSld>
+    <p:spTree>
+      <p:nvGrpSpPr>
+        <p:cNvPr id="1" name=""/>
+        <p:cNvGrpSpPr/>
+        <p:nvPr/>
+      </p:nvGrpSpPr>
+      <p:grpSpPr>
+        <a:xfrm>
+          <a:off x="0" y="0"/>
+          <a:ext cx="0" cy="0"/>
+          <a:chOff x="0" y="0"/>
+          <a:chExt cx="0" cy="0"/>
+        </a:xfrm>
+      </p:grpSpPr>
+      <p:sp>
+        <p:nvSpPr>
+          <p:cNvPr id="2" name="Titel 1">
+            <a:extLst>
+              <a:ext uri="{FF2B5EF4-FFF2-40B4-BE49-F238E27FC236}">
+                <a16:creationId xmlns:a16="http://schemas.microsoft.com/office/drawing/2014/main" id="{2BFF6D26-5A50-8993-25E9-810FC265BA42}"/>
+              </a:ext>
+            </a:extLst>
+          </p:cNvPr>
+          <p:cNvSpPr>
+            <a:spLocks noGrp="1"/>
+          </p:cNvSpPr>
+          <p:nvPr>
+            <p:ph type="title"/>
+          </p:nvPr>
+        </p:nvSpPr>
+        <p:spPr/>
+        <p:txBody>
+          <a:bodyPr/>
+          <a:lstStyle/>
+          <a:p>
+            <a:r>
+              <a:rPr lang="de-DE" dirty="0"/>
+              <a:t>Pyroutelib2-route.py</a:t>
+            </a:r>
+          </a:p>
+        </p:txBody>
+      </p:sp>
+      <p:sp>
+        <p:nvSpPr>
+          <p:cNvPr id="4" name="Datumsplatzhalter 3">
+            <a:extLst>
+              <a:ext uri="{FF2B5EF4-FFF2-40B4-BE49-F238E27FC236}">
+                <a16:creationId xmlns:a16="http://schemas.microsoft.com/office/drawing/2014/main" id="{B8D4E00D-11F6-C995-874E-A950660F1DEE}"/>
+              </a:ext>
+            </a:extLst>
+          </p:cNvPr>
+          <p:cNvSpPr>
+            <a:spLocks noGrp="1"/>
+          </p:cNvSpPr>
+          <p:nvPr>
+            <p:ph type="dt" sz="half" idx="10"/>
+          </p:nvPr>
+        </p:nvSpPr>
+        <p:spPr/>
+        <p:txBody>
+          <a:bodyPr/>
+          <a:lstStyle/>
+          <a:p>
+            <a:fld id="{12798F19-8D51-794B-8ACF-FCEE93C20526}" type="datetime1">
+              <a:rPr lang="de-DE" smtClean="0"/>
+              <a:t>21.10.2024</a:t>
+            </a:fld>
+            <a:endParaRPr lang="en-DE"/>
+          </a:p>
+        </p:txBody>
+      </p:sp>
+      <p:sp>
+        <p:nvSpPr>
+          <p:cNvPr id="5" name="Foliennummernplatzhalter 4">
+            <a:extLst>
+              <a:ext uri="{FF2B5EF4-FFF2-40B4-BE49-F238E27FC236}">
+                <a16:creationId xmlns:a16="http://schemas.microsoft.com/office/drawing/2014/main" id="{4509AB43-04D2-2833-8602-E6FFEFF28E70}"/>
+              </a:ext>
+            </a:extLst>
+          </p:cNvPr>
+          <p:cNvSpPr>
+            <a:spLocks noGrp="1"/>
+          </p:cNvSpPr>
+          <p:nvPr>
+            <p:ph type="sldNum" sz="quarter" idx="12"/>
+          </p:nvPr>
+        </p:nvSpPr>
+        <p:spPr/>
+        <p:txBody>
+          <a:bodyPr/>
+          <a:lstStyle/>
+          <a:p>
+            <a:fld id="{1148E9C0-692D-B340-AF6F-432654B065A1}" type="slidenum">
+              <a:rPr lang="en-DE" smtClean="0"/>
+              <a:t>10</a:t>
+            </a:fld>
+            <a:endParaRPr lang="en-DE"/>
+          </a:p>
+        </p:txBody>
+      </p:sp>
+      <p:pic>
+        <p:nvPicPr>
+          <p:cNvPr id="7" name="Grafik 6">
+            <a:extLst>
+              <a:ext uri="{FF2B5EF4-FFF2-40B4-BE49-F238E27FC236}">
+                <a16:creationId xmlns:a16="http://schemas.microsoft.com/office/drawing/2014/main" id="{0CF45F9B-1A39-838E-149B-7EE71ABFCAB5}"/>
+              </a:ext>
+            </a:extLst>
+          </p:cNvPr>
+          <p:cNvPicPr>
+            <a:picLocks noChangeAspect="1"/>
+          </p:cNvPicPr>
+          <p:nvPr/>
+        </p:nvPicPr>
+        <p:blipFill>
+          <a:blip r:embed="rId2"/>
+          <a:stretch>
+            <a:fillRect/>
+          </a:stretch>
+        </p:blipFill>
+        <p:spPr>
+          <a:xfrm>
+            <a:off x="1757182" y="1418400"/>
+            <a:ext cx="5629275" cy="5020511"/>
+          </a:xfrm>
+          <a:prstGeom prst="rect">
+            <a:avLst/>
+          </a:prstGeom>
+        </p:spPr>
+      </p:pic>
+    </p:spTree>
+    <p:extLst>
+      <p:ext uri="{BB962C8B-B14F-4D97-AF65-F5344CB8AC3E}">
+        <p14:creationId xmlns:p14="http://schemas.microsoft.com/office/powerpoint/2010/main" val="2819760152"/>
+      </p:ext>
+    </p:extLst>
+  </p:cSld>
+  <p:clrMapOvr>
+    <a:masterClrMapping/>
+  </p:clrMapOvr>
+</p:sld>
+</file>
+
+<file path=ppt/slides/slide12.xml><?xml version="1.0" encoding="utf-8"?>
+<p:sld xmlns:a="http://schemas.openxmlformats.org/drawingml/2006/main" xmlns:r="http://schemas.openxmlformats.org/officeDocument/2006/relationships" xmlns:p="http://schemas.openxmlformats.org/presentationml/2006/main">
+  <p:cSld>
+    <p:spTree>
+      <p:nvGrpSpPr>
+        <p:cNvPr id="1" name=""/>
+        <p:cNvGrpSpPr/>
+        <p:nvPr/>
+      </p:nvGrpSpPr>
+      <p:grpSpPr>
+        <a:xfrm>
+          <a:off x="0" y="0"/>
+          <a:ext cx="0" cy="0"/>
+          <a:chOff x="0" y="0"/>
+          <a:chExt cx="0" cy="0"/>
+        </a:xfrm>
+      </p:grpSpPr>
+      <p:sp>
+        <p:nvSpPr>
+          <p:cNvPr id="2" name="Titel 1">
+            <a:extLst>
+              <a:ext uri="{FF2B5EF4-FFF2-40B4-BE49-F238E27FC236}">
+                <a16:creationId xmlns:a16="http://schemas.microsoft.com/office/drawing/2014/main" id="{E21BAD64-3A7E-976B-BF22-93BF6B76A095}"/>
+              </a:ext>
+            </a:extLst>
+          </p:cNvPr>
+          <p:cNvSpPr>
+            <a:spLocks noGrp="1"/>
+          </p:cNvSpPr>
+          <p:nvPr>
+            <p:ph type="title"/>
+          </p:nvPr>
+        </p:nvSpPr>
+        <p:spPr/>
+        <p:txBody>
+          <a:bodyPr/>
+          <a:lstStyle/>
+          <a:p>
+            <a:r>
+              <a:rPr lang="de-DE" dirty="0"/>
+              <a:t>Pyroutelib2-route.py</a:t>
+            </a:r>
+          </a:p>
+        </p:txBody>
+      </p:sp>
+      <p:sp>
+        <p:nvSpPr>
+          <p:cNvPr id="4" name="Datumsplatzhalter 3">
+            <a:extLst>
+              <a:ext uri="{FF2B5EF4-FFF2-40B4-BE49-F238E27FC236}">
+                <a16:creationId xmlns:a16="http://schemas.microsoft.com/office/drawing/2014/main" id="{E7CBA799-EDBD-D537-D083-C0EF58358147}"/>
+              </a:ext>
+            </a:extLst>
+          </p:cNvPr>
+          <p:cNvSpPr>
+            <a:spLocks noGrp="1"/>
+          </p:cNvSpPr>
+          <p:nvPr>
+            <p:ph type="dt" sz="half" idx="10"/>
+          </p:nvPr>
+        </p:nvSpPr>
+        <p:spPr/>
+        <p:txBody>
+          <a:bodyPr/>
+          <a:lstStyle/>
+          <a:p>
+            <a:fld id="{12798F19-8D51-794B-8ACF-FCEE93C20526}" type="datetime1">
+              <a:rPr lang="de-DE" smtClean="0"/>
+              <a:t>21.10.2024</a:t>
+            </a:fld>
+            <a:endParaRPr lang="en-DE"/>
+          </a:p>
+        </p:txBody>
+      </p:sp>
+      <p:sp>
+        <p:nvSpPr>
+          <p:cNvPr id="5" name="Foliennummernplatzhalter 4">
+            <a:extLst>
+              <a:ext uri="{FF2B5EF4-FFF2-40B4-BE49-F238E27FC236}">
+                <a16:creationId xmlns:a16="http://schemas.microsoft.com/office/drawing/2014/main" id="{5A16E5CD-D72A-FB85-1954-F3B9D45ABB36}"/>
+              </a:ext>
+            </a:extLst>
+          </p:cNvPr>
+          <p:cNvSpPr>
+            <a:spLocks noGrp="1"/>
+          </p:cNvSpPr>
+          <p:nvPr>
+            <p:ph type="sldNum" sz="quarter" idx="12"/>
+          </p:nvPr>
+        </p:nvSpPr>
+        <p:spPr/>
+        <p:txBody>
+          <a:bodyPr/>
+          <a:lstStyle/>
+          <a:p>
+            <a:fld id="{1148E9C0-692D-B340-AF6F-432654B065A1}" type="slidenum">
+              <a:rPr lang="en-DE" smtClean="0"/>
+              <a:t>11</a:t>
+            </a:fld>
+            <a:endParaRPr lang="en-DE"/>
+          </a:p>
+        </p:txBody>
+      </p:sp>
+      <p:pic>
+        <p:nvPicPr>
+          <p:cNvPr id="7" name="Grafik 6">
+            <a:extLst>
+              <a:ext uri="{FF2B5EF4-FFF2-40B4-BE49-F238E27FC236}">
+                <a16:creationId xmlns:a16="http://schemas.microsoft.com/office/drawing/2014/main" id="{C7C00FB5-945D-E4BF-0E82-D569A3309E3F}"/>
+              </a:ext>
+            </a:extLst>
+          </p:cNvPr>
+          <p:cNvPicPr>
+            <a:picLocks noChangeAspect="1"/>
+          </p:cNvPicPr>
+          <p:nvPr/>
+        </p:nvPicPr>
+        <p:blipFill>
+          <a:blip r:embed="rId2"/>
+          <a:stretch>
+            <a:fillRect/>
+          </a:stretch>
+        </p:blipFill>
+        <p:spPr>
+          <a:xfrm>
+            <a:off x="386572" y="1981200"/>
+            <a:ext cx="8370856" cy="3161168"/>
+          </a:xfrm>
+          <a:prstGeom prst="rect">
+            <a:avLst/>
+          </a:prstGeom>
+        </p:spPr>
+      </p:pic>
+    </p:spTree>
+    <p:extLst>
+      <p:ext uri="{BB962C8B-B14F-4D97-AF65-F5344CB8AC3E}">
+        <p14:creationId xmlns:p14="http://schemas.microsoft.com/office/powerpoint/2010/main" val="2240480974"/>
+      </p:ext>
+    </p:extLst>
+  </p:cSld>
+  <p:clrMapOvr>
+    <a:masterClrMapping/>
+  </p:clrMapOvr>
+</p:sld>
+</file>
+
+<file path=ppt/slides/slide13.xml><?xml version="1.0" encoding="utf-8"?>
+<p:sld xmlns:a="http://schemas.openxmlformats.org/drawingml/2006/main" xmlns:r="http://schemas.openxmlformats.org/officeDocument/2006/relationships" xmlns:p="http://schemas.openxmlformats.org/presentationml/2006/main">
+  <p:cSld>
+    <p:spTree>
+      <p:nvGrpSpPr>
+        <p:cNvPr id="1" name="">
+          <a:extLst>
+            <a:ext uri="{FF2B5EF4-FFF2-40B4-BE49-F238E27FC236}">
+              <a16:creationId xmlns:a16="http://schemas.microsoft.com/office/drawing/2014/main" id="{ADF71303-0FCE-DA02-7DE4-706BA33E248B}"/>
+            </a:ext>
+          </a:extLst>
+        </p:cNvPr>
+        <p:cNvGrpSpPr/>
+        <p:nvPr/>
+      </p:nvGrpSpPr>
+      <p:grpSpPr>
+        <a:xfrm>
+          <a:off x="0" y="0"/>
+          <a:ext cx="0" cy="0"/>
+          <a:chOff x="0" y="0"/>
+          <a:chExt cx="0" cy="0"/>
+        </a:xfrm>
+      </p:grpSpPr>
+      <p:sp>
+        <p:nvSpPr>
+          <p:cNvPr id="97" name="CustomShape 1">
+            <a:extLst>
+              <a:ext uri="{FF2B5EF4-FFF2-40B4-BE49-F238E27FC236}">
+                <a16:creationId xmlns:a16="http://schemas.microsoft.com/office/drawing/2014/main" id="{9F5AF313-AE81-79FA-5742-52D5EBF4783B}"/>
+              </a:ext>
+            </a:extLst>
+          </p:cNvPr>
+          <p:cNvSpPr/>
+          <p:nvPr/>
+        </p:nvSpPr>
+        <p:spPr>
+          <a:xfrm>
+            <a:off x="457200" y="699120"/>
+            <a:ext cx="7883280" cy="469800"/>
+          </a:xfrm>
+          <a:prstGeom prst="rect">
+            <a:avLst/>
+          </a:prstGeom>
+          <a:noFill/>
+          <a:ln w="0">
+            <a:noFill/>
+          </a:ln>
+        </p:spPr>
+        <p:style>
+          <a:lnRef idx="0">
+            <a:scrgbClr r="0" g="0" b="0"/>
+          </a:lnRef>
+          <a:fillRef idx="0">
+            <a:scrgbClr r="0" g="0" b="0"/>
+          </a:fillRef>
+          <a:effectRef idx="0">
+            <a:scrgbClr r="0" g="0" b="0"/>
+          </a:effectRef>
+          <a:fontRef idx="minor"/>
+        </p:style>
+        <p:txBody>
+          <a:bodyPr lIns="90000" tIns="45000" rIns="90000" bIns="45000" anchor="ctr">
+            <a:noAutofit/>
+          </a:bodyPr>
+          <a:lstStyle/>
+          <a:p>
+            <a:pPr>
+              <a:lnSpc>
+                <a:spcPct val="100000"/>
+              </a:lnSpc>
+              <a:buNone/>
+            </a:pPr>
+            <a:r>
+              <a:rPr lang="en-DE" sz="2400" dirty="0"/>
+              <a:t>23.10.2024 Team Visualisierung</a:t>
+            </a:r>
+            <a:endParaRPr lang="en-US" sz="2400" b="0" strike="noStrike" spc="-1" dirty="0">
+              <a:solidFill>
+                <a:srgbClr val="000000"/>
+              </a:solidFill>
+              <a:latin typeface="Arial"/>
+            </a:endParaRPr>
+          </a:p>
+        </p:txBody>
+      </p:sp>
+      <p:sp>
+        <p:nvSpPr>
+          <p:cNvPr id="2" name="TextBox 1">
+            <a:extLst>
+              <a:ext uri="{FF2B5EF4-FFF2-40B4-BE49-F238E27FC236}">
+                <a16:creationId xmlns:a16="http://schemas.microsoft.com/office/drawing/2014/main" id="{57D21ABF-46E7-470F-8411-020A0C41F70A}"/>
+              </a:ext>
+            </a:extLst>
+          </p:cNvPr>
+          <p:cNvSpPr txBox="1"/>
+          <p:nvPr/>
+        </p:nvSpPr>
+        <p:spPr>
+          <a:xfrm>
+            <a:off x="457200" y="1682496"/>
+            <a:ext cx="6833616" cy="646331"/>
+          </a:xfrm>
+          <a:prstGeom prst="rect">
+            <a:avLst/>
+          </a:prstGeom>
+          <a:noFill/>
+        </p:spPr>
+        <p:txBody>
+          <a:bodyPr wrap="square" rtlCol="0">
+            <a:spAutoFit/>
+          </a:bodyPr>
+          <a:lstStyle/>
+          <a:p>
+            <a:r>
+              <a:rPr lang="en-GB" dirty="0" err="1">
+                <a:effectLst/>
+                <a:latin typeface="Helvetica" pitchFamily="2" charset="0"/>
+              </a:rPr>
+              <a:t>Möglichkeiten</a:t>
+            </a:r>
+            <a:r>
+              <a:rPr lang="en-GB" dirty="0">
+                <a:effectLst/>
+                <a:latin typeface="Helvetica" pitchFamily="2" charset="0"/>
+              </a:rPr>
+              <a:t> die </a:t>
+            </a:r>
+            <a:r>
+              <a:rPr lang="en-GB" dirty="0" err="1">
+                <a:effectLst/>
+                <a:latin typeface="Helvetica" pitchFamily="2" charset="0"/>
+              </a:rPr>
+              <a:t>openstreetmap</a:t>
+            </a:r>
+            <a:r>
+              <a:rPr lang="en-GB" dirty="0">
+                <a:effectLst/>
+                <a:latin typeface="Helvetica" pitchFamily="2" charset="0"/>
+              </a:rPr>
+              <a:t> (</a:t>
+            </a:r>
+            <a:r>
+              <a:rPr lang="en-GB" dirty="0" err="1">
+                <a:effectLst/>
+                <a:latin typeface="Helvetica" pitchFamily="2" charset="0"/>
+              </a:rPr>
+              <a:t>lokal</a:t>
+            </a:r>
+            <a:r>
+              <a:rPr lang="en-GB" dirty="0">
+                <a:effectLst/>
+                <a:latin typeface="Helvetica" pitchFamily="2" charset="0"/>
+              </a:rPr>
+              <a:t>) </a:t>
+            </a:r>
+            <a:r>
+              <a:rPr lang="en-GB" dirty="0" err="1">
+                <a:effectLst/>
+                <a:latin typeface="Helvetica" pitchFamily="2" charset="0"/>
+              </a:rPr>
+              <a:t>zu</a:t>
+            </a:r>
+            <a:r>
+              <a:rPr lang="en-GB" dirty="0">
+                <a:effectLst/>
+                <a:latin typeface="Helvetica" pitchFamily="2" charset="0"/>
+              </a:rPr>
+              <a:t> </a:t>
+            </a:r>
+            <a:r>
+              <a:rPr lang="en-GB" dirty="0" err="1">
+                <a:effectLst/>
+                <a:latin typeface="Helvetica" pitchFamily="2" charset="0"/>
+              </a:rPr>
+              <a:t>visualisieren</a:t>
+            </a:r>
+            <a:endParaRPr lang="en-GB" dirty="0">
+              <a:effectLst/>
+              <a:latin typeface="Helvetica" pitchFamily="2" charset="0"/>
+            </a:endParaRPr>
+          </a:p>
+          <a:p>
+            <a:r>
+              <a:rPr lang="en-GB" dirty="0" err="1">
+                <a:effectLst/>
+                <a:latin typeface="Helvetica" pitchFamily="2" charset="0"/>
+              </a:rPr>
+              <a:t>Welche</a:t>
+            </a:r>
+            <a:r>
+              <a:rPr lang="en-GB" dirty="0">
+                <a:effectLst/>
+                <a:latin typeface="Helvetica" pitchFamily="2" charset="0"/>
+              </a:rPr>
+              <a:t> </a:t>
+            </a:r>
+            <a:r>
+              <a:rPr lang="en-GB" dirty="0" err="1">
+                <a:effectLst/>
+                <a:latin typeface="Helvetica" pitchFamily="2" charset="0"/>
+              </a:rPr>
+              <a:t>Daten</a:t>
+            </a:r>
+            <a:r>
+              <a:rPr lang="en-GB" dirty="0">
+                <a:effectLst/>
+                <a:latin typeface="Helvetica" pitchFamily="2" charset="0"/>
+              </a:rPr>
+              <a:t> </a:t>
+            </a:r>
+            <a:r>
+              <a:rPr lang="en-GB" dirty="0" err="1">
+                <a:effectLst/>
+                <a:latin typeface="Helvetica" pitchFamily="2" charset="0"/>
+              </a:rPr>
+              <a:t>könnten</a:t>
+            </a:r>
+            <a:r>
+              <a:rPr lang="en-GB" dirty="0">
+                <a:effectLst/>
+                <a:latin typeface="Helvetica" pitchFamily="2" charset="0"/>
+              </a:rPr>
+              <a:t> </a:t>
+            </a:r>
+            <a:r>
+              <a:rPr lang="en-GB" dirty="0" err="1">
+                <a:effectLst/>
+                <a:latin typeface="Helvetica" pitchFamily="2" charset="0"/>
+              </a:rPr>
+              <a:t>visualisiert</a:t>
+            </a:r>
+            <a:r>
+              <a:rPr lang="en-GB" dirty="0">
+                <a:effectLst/>
+                <a:latin typeface="Helvetica" pitchFamily="2" charset="0"/>
+              </a:rPr>
+              <a:t> </a:t>
+            </a:r>
+            <a:r>
+              <a:rPr lang="en-GB" dirty="0" err="1">
+                <a:effectLst/>
+                <a:latin typeface="Helvetica" pitchFamily="2" charset="0"/>
+              </a:rPr>
+              <a:t>werden</a:t>
+            </a:r>
+            <a:endParaRPr lang="en-GB" dirty="0">
+              <a:effectLst/>
+              <a:latin typeface="Helvetica" pitchFamily="2" charset="0"/>
+            </a:endParaRPr>
+          </a:p>
+        </p:txBody>
+      </p:sp>
+      <p:sp>
+        <p:nvSpPr>
+          <p:cNvPr id="5" name="Date Placeholder 4">
+            <a:extLst>
+              <a:ext uri="{FF2B5EF4-FFF2-40B4-BE49-F238E27FC236}">
+                <a16:creationId xmlns:a16="http://schemas.microsoft.com/office/drawing/2014/main" id="{2098A1C1-C6E3-36DB-1A7D-C511DC4678E4}"/>
+              </a:ext>
+            </a:extLst>
+          </p:cNvPr>
+          <p:cNvSpPr>
+            <a:spLocks noGrp="1"/>
+          </p:cNvSpPr>
+          <p:nvPr>
+            <p:ph type="dt" sz="half" idx="10"/>
+          </p:nvPr>
+        </p:nvSpPr>
+        <p:spPr/>
+        <p:txBody>
+          <a:bodyPr/>
+          <a:lstStyle/>
+          <a:p>
+            <a:fld id="{0FBC0988-905C-AB41-86EF-B70567269C0A}" type="datetime1">
+              <a:rPr lang="de-DE" smtClean="0"/>
+              <a:t>21.10.2024</a:t>
+            </a:fld>
+            <a:endParaRPr lang="en-DE" dirty="0"/>
+          </a:p>
+        </p:txBody>
+      </p:sp>
+      <p:sp>
+        <p:nvSpPr>
+          <p:cNvPr id="6" name="Slide Number Placeholder 5">
+            <a:extLst>
+              <a:ext uri="{FF2B5EF4-FFF2-40B4-BE49-F238E27FC236}">
+                <a16:creationId xmlns:a16="http://schemas.microsoft.com/office/drawing/2014/main" id="{6FD8A319-FC07-1A9E-C96D-E7A13789C453}"/>
+              </a:ext>
+            </a:extLst>
+          </p:cNvPr>
+          <p:cNvSpPr>
+            <a:spLocks noGrp="1"/>
+          </p:cNvSpPr>
+          <p:nvPr>
+            <p:ph type="sldNum" sz="quarter" idx="12"/>
+          </p:nvPr>
+        </p:nvSpPr>
+        <p:spPr/>
+        <p:txBody>
+          <a:bodyPr/>
+          <a:lstStyle/>
+          <a:p>
+            <a:fld id="{1148E9C0-692D-B340-AF6F-432654B065A1}" type="slidenum">
+              <a:rPr lang="en-DE" smtClean="0"/>
+              <a:t>12</a:t>
+            </a:fld>
+            <a:endParaRPr lang="en-DE" dirty="0"/>
+          </a:p>
+        </p:txBody>
+      </p:sp>
+    </p:spTree>
+    <p:extLst>
+      <p:ext uri="{BB962C8B-B14F-4D97-AF65-F5344CB8AC3E}">
+        <p14:creationId xmlns:p14="http://schemas.microsoft.com/office/powerpoint/2010/main" val="947827265"/>
+      </p:ext>
+    </p:extLst>
+  </p:cSld>
+  <p:clrMapOvr>
+    <a:masterClrMapping/>
+  </p:clrMapOvr>
+</p:sld>
+</file>
+
 <file path=ppt/slides/slide2.xml><?xml version="1.0" encoding="utf-8"?>
 <p:sld xmlns:a="http://schemas.openxmlformats.org/drawingml/2006/main" xmlns:r="http://schemas.openxmlformats.org/officeDocument/2006/relationships" xmlns:p="http://schemas.openxmlformats.org/presentationml/2006/main">
   <p:cSld>
@@ -8842,7 +9660,7 @@
           <a:p>
             <a:fld id="{67FB260B-9787-2941-BD6E-E8B8AEB1B5A8}" type="datetime1">
               <a:rPr lang="de-DE" smtClean="0"/>
-              <a:t>16.10.24</a:t>
+              <a:t>21.10.2024</a:t>
             </a:fld>
             <a:endParaRPr lang="en-DE" dirty="0"/>
           </a:p>
@@ -8907,6 +9725,42 @@
           <a:chExt cx="0" cy="0"/>
         </a:xfrm>
       </p:grpSpPr>
+      <p:pic>
+        <p:nvPicPr>
+          <p:cNvPr id="4" name="Grafik 3">
+            <a:extLst>
+              <a:ext uri="{FF2B5EF4-FFF2-40B4-BE49-F238E27FC236}">
+                <a16:creationId xmlns:a16="http://schemas.microsoft.com/office/drawing/2014/main" id="{16A49187-2370-3FA5-6434-FDD93EF9AB0F}"/>
+              </a:ext>
+            </a:extLst>
+          </p:cNvPr>
+          <p:cNvPicPr>
+            <a:picLocks noChangeAspect="1"/>
+          </p:cNvPicPr>
+          <p:nvPr/>
+        </p:nvPicPr>
+        <p:blipFill>
+          <a:blip r:embed="rId2">
+            <a:extLst>
+              <a:ext uri="{28A0092B-C50C-407E-A947-70E740481C1C}">
+                <a14:useLocalDpi xmlns:a14="http://schemas.microsoft.com/office/drawing/2010/main" val="0"/>
+              </a:ext>
+            </a:extLst>
+          </a:blip>
+          <a:stretch>
+            <a:fillRect/>
+          </a:stretch>
+        </p:blipFill>
+        <p:spPr>
+          <a:xfrm>
+            <a:off x="842715" y="2316777"/>
+            <a:ext cx="7239000" cy="1524000"/>
+          </a:xfrm>
+          <a:prstGeom prst="rect">
+            <a:avLst/>
+          </a:prstGeom>
+        </p:spPr>
+      </p:pic>
       <p:sp>
         <p:nvSpPr>
           <p:cNvPr id="97" name="CustomShape 1"/>
@@ -9062,7 +9916,7 @@
           <a:p>
             <a:fld id="{0FBC0988-905C-AB41-86EF-B70567269C0A}" type="datetime1">
               <a:rPr lang="de-DE" smtClean="0"/>
-              <a:t>16.10.24</a:t>
+              <a:t>21.10.2024</a:t>
             </a:fld>
             <a:endParaRPr lang="en-DE" dirty="0"/>
           </a:p>
@@ -9166,6 +10020,113 @@
               <a:buChar char="-"/>
             </a:pPr>
             <a:endParaRPr lang="en-DE" dirty="0"/>
+          </a:p>
+        </p:txBody>
+      </p:sp>
+      <p:sp>
+        <p:nvSpPr>
+          <p:cNvPr id="7" name="Textfeld 6">
+            <a:extLst>
+              <a:ext uri="{FF2B5EF4-FFF2-40B4-BE49-F238E27FC236}">
+                <a16:creationId xmlns:a16="http://schemas.microsoft.com/office/drawing/2014/main" id="{C9E152B0-E6D7-F809-7B03-53A4A5B83749}"/>
+              </a:ext>
+            </a:extLst>
+          </p:cNvPr>
+          <p:cNvSpPr txBox="1"/>
+          <p:nvPr/>
+        </p:nvSpPr>
+        <p:spPr>
+          <a:xfrm>
+            <a:off x="6457950" y="3415320"/>
+            <a:ext cx="992579" cy="369332"/>
+          </a:xfrm>
+          <a:prstGeom prst="rect">
+            <a:avLst/>
+          </a:prstGeom>
+          <a:noFill/>
+        </p:spPr>
+        <p:txBody>
+          <a:bodyPr wrap="none" rtlCol="0">
+            <a:spAutoFit/>
+          </a:bodyPr>
+          <a:lstStyle/>
+          <a:p>
+            <a:r>
+              <a:rPr lang="de-DE" dirty="0" err="1"/>
+              <a:t>Generic</a:t>
+            </a:r>
+            <a:endParaRPr lang="de-DE" dirty="0"/>
+          </a:p>
+        </p:txBody>
+      </p:sp>
+      <p:sp>
+        <p:nvSpPr>
+          <p:cNvPr id="9" name="Textfeld 8">
+            <a:extLst>
+              <a:ext uri="{FF2B5EF4-FFF2-40B4-BE49-F238E27FC236}">
+                <a16:creationId xmlns:a16="http://schemas.microsoft.com/office/drawing/2014/main" id="{7CE71015-BB16-22EB-662F-B51A9AD1042A}"/>
+              </a:ext>
+            </a:extLst>
+          </p:cNvPr>
+          <p:cNvSpPr txBox="1"/>
+          <p:nvPr/>
+        </p:nvSpPr>
+        <p:spPr>
+          <a:xfrm>
+            <a:off x="4056438" y="3489607"/>
+            <a:ext cx="684803" cy="369332"/>
+          </a:xfrm>
+          <a:prstGeom prst="rect">
+            <a:avLst/>
+          </a:prstGeom>
+          <a:noFill/>
+        </p:spPr>
+        <p:txBody>
+          <a:bodyPr wrap="none" rtlCol="0">
+            <a:spAutoFit/>
+          </a:bodyPr>
+          <a:lstStyle/>
+          <a:p>
+            <a:r>
+              <a:rPr lang="de-DE" dirty="0"/>
+              <a:t>Core</a:t>
+            </a:r>
+          </a:p>
+        </p:txBody>
+      </p:sp>
+      <p:sp>
+        <p:nvSpPr>
+          <p:cNvPr id="10" name="Textfeld 9">
+            <a:extLst>
+              <a:ext uri="{FF2B5EF4-FFF2-40B4-BE49-F238E27FC236}">
+                <a16:creationId xmlns:a16="http://schemas.microsoft.com/office/drawing/2014/main" id="{AAAAE687-17AE-62A7-5496-F7DD7966E1DF}"/>
+              </a:ext>
+            </a:extLst>
+          </p:cNvPr>
+          <p:cNvSpPr txBox="1"/>
+          <p:nvPr/>
+        </p:nvSpPr>
+        <p:spPr>
+          <a:xfrm>
+            <a:off x="1211389" y="3429000"/>
+            <a:ext cx="1300356" cy="369332"/>
+          </a:xfrm>
+          <a:prstGeom prst="rect">
+            <a:avLst/>
+          </a:prstGeom>
+          <a:noFill/>
+        </p:spPr>
+        <p:txBody>
+          <a:bodyPr wrap="none" rtlCol="0">
+            <a:spAutoFit/>
+          </a:bodyPr>
+          <a:lstStyle/>
+          <a:p>
+            <a:r>
+              <a:rPr lang="de-DE" dirty="0" err="1"/>
+              <a:t>Supporting</a:t>
+            </a:r>
+            <a:endParaRPr lang="de-DE" dirty="0"/>
           </a:p>
         </p:txBody>
       </p:sp>
@@ -10025,7 +10986,7 @@
           <a:p>
             <a:fld id="{0FBC0988-905C-AB41-86EF-B70567269C0A}" type="datetime1">
               <a:rPr lang="de-DE" smtClean="0"/>
-              <a:t>16.10.24</a:t>
+              <a:t>21.10.2024</a:t>
             </a:fld>
             <a:endParaRPr lang="en-DE" dirty="0"/>
           </a:p>
@@ -10282,7 +11243,7 @@
           <a:p>
             <a:fld id="{0FBC0988-905C-AB41-86EF-B70567269C0A}" type="datetime1">
               <a:rPr lang="de-DE" smtClean="0"/>
-              <a:t>16.10.24</a:t>
+              <a:t>21.10.2024</a:t>
             </a:fld>
             <a:endParaRPr lang="en-DE" dirty="0"/>
           </a:p>
@@ -10429,7 +11390,7 @@
         </p:nvSpPr>
         <p:spPr>
           <a:xfrm>
-            <a:off x="457200" y="1682496"/>
+            <a:off x="1155192" y="3105834"/>
             <a:ext cx="6833616" cy="646331"/>
           </a:xfrm>
           <a:prstGeom prst="rect">
@@ -10443,6 +11404,7 @@
           </a:bodyPr>
           <a:lstStyle/>
           <a:p>
+            <a:pPr algn="ctr"/>
             <a:r>
               <a:rPr lang="en-GB" dirty="0" err="1">
                 <a:effectLst/>
@@ -10637,7 +11599,7 @@
           <a:p>
             <a:fld id="{0FBC0988-905C-AB41-86EF-B70567269C0A}" type="datetime1">
               <a:rPr lang="de-DE" smtClean="0"/>
-              <a:t>16.10.24</a:t>
+              <a:t>21.10.2024</a:t>
             </a:fld>
             <a:endParaRPr lang="en-DE" dirty="0"/>
           </a:p>
@@ -10690,13 +11652,7 @@
   <p:cSld>
     <p:spTree>
       <p:nvGrpSpPr>
-        <p:cNvPr id="1" name="">
-          <a:extLst>
-            <a:ext uri="{FF2B5EF4-FFF2-40B4-BE49-F238E27FC236}">
-              <a16:creationId xmlns:a16="http://schemas.microsoft.com/office/drawing/2014/main" id="{ADF71303-0FCE-DA02-7DE4-706BA33E248B}"/>
-            </a:ext>
-          </a:extLst>
-        </p:cNvPr>
+        <p:cNvPr id="1" name=""/>
         <p:cNvGrpSpPr/>
         <p:nvPr/>
       </p:nvGrpSpPr>
@@ -10710,239 +11666,38 @@
       </p:grpSpPr>
       <p:sp>
         <p:nvSpPr>
-          <p:cNvPr id="97" name="CustomShape 1">
-            <a:extLst>
-              <a:ext uri="{FF2B5EF4-FFF2-40B4-BE49-F238E27FC236}">
-                <a16:creationId xmlns:a16="http://schemas.microsoft.com/office/drawing/2014/main" id="{9F5AF313-AE81-79FA-5742-52D5EBF4783B}"/>
-              </a:ext>
-            </a:extLst>
-          </p:cNvPr>
-          <p:cNvSpPr/>
-          <p:nvPr/>
-        </p:nvSpPr>
-        <p:spPr>
-          <a:xfrm>
-            <a:off x="457200" y="699120"/>
-            <a:ext cx="7883280" cy="469800"/>
-          </a:xfrm>
-          <a:prstGeom prst="rect">
-            <a:avLst/>
-          </a:prstGeom>
-          <a:noFill/>
-          <a:ln w="0">
-            <a:noFill/>
-          </a:ln>
-        </p:spPr>
-        <p:style>
-          <a:lnRef idx="0">
-            <a:scrgbClr r="0" g="0" b="0"/>
-          </a:lnRef>
-          <a:fillRef idx="0">
-            <a:scrgbClr r="0" g="0" b="0"/>
-          </a:fillRef>
-          <a:effectRef idx="0">
-            <a:scrgbClr r="0" g="0" b="0"/>
-          </a:effectRef>
-          <a:fontRef idx="minor"/>
-        </p:style>
-        <p:txBody>
-          <a:bodyPr lIns="90000" tIns="45000" rIns="90000" bIns="45000" anchor="ctr">
-            <a:noAutofit/>
-          </a:bodyPr>
-          <a:lstStyle/>
-          <a:p>
-            <a:pPr>
-              <a:lnSpc>
-                <a:spcPct val="100000"/>
-              </a:lnSpc>
-              <a:buNone/>
-            </a:pPr>
-            <a:r>
-              <a:rPr lang="en-DE" sz="2400" dirty="0"/>
-              <a:t>23.10.2024 Team Visualisierung</a:t>
-            </a:r>
-            <a:endParaRPr lang="en-US" sz="2400" b="0" strike="noStrike" spc="-1" dirty="0">
-              <a:solidFill>
-                <a:srgbClr val="000000"/>
-              </a:solidFill>
-              <a:latin typeface="Arial"/>
-            </a:endParaRPr>
-          </a:p>
-        </p:txBody>
-      </p:sp>
-      <p:sp>
-        <p:nvSpPr>
-          <p:cNvPr id="2" name="TextBox 1">
-            <a:extLst>
-              <a:ext uri="{FF2B5EF4-FFF2-40B4-BE49-F238E27FC236}">
-                <a16:creationId xmlns:a16="http://schemas.microsoft.com/office/drawing/2014/main" id="{57D21ABF-46E7-470F-8411-020A0C41F70A}"/>
-              </a:ext>
-            </a:extLst>
-          </p:cNvPr>
-          <p:cNvSpPr txBox="1"/>
-          <p:nvPr/>
-        </p:nvSpPr>
-        <p:spPr>
-          <a:xfrm>
-            <a:off x="457200" y="1682496"/>
-            <a:ext cx="6833616" cy="646331"/>
-          </a:xfrm>
-          <a:prstGeom prst="rect">
-            <a:avLst/>
-          </a:prstGeom>
-          <a:noFill/>
-        </p:spPr>
-        <p:txBody>
-          <a:bodyPr wrap="square" rtlCol="0">
-            <a:spAutoFit/>
-          </a:bodyPr>
-          <a:lstStyle/>
-          <a:p>
-            <a:r>
-              <a:rPr lang="en-GB" dirty="0" err="1">
-                <a:effectLst/>
-                <a:latin typeface="Helvetica" pitchFamily="2" charset="0"/>
-              </a:rPr>
-              <a:t>Möglichkeiten</a:t>
-            </a:r>
-            <a:r>
-              <a:rPr lang="en-GB" dirty="0">
-                <a:effectLst/>
-                <a:latin typeface="Helvetica" pitchFamily="2" charset="0"/>
-              </a:rPr>
-              <a:t> die </a:t>
-            </a:r>
-            <a:r>
-              <a:rPr lang="en-GB" dirty="0" err="1">
-                <a:effectLst/>
-                <a:latin typeface="Helvetica" pitchFamily="2" charset="0"/>
-              </a:rPr>
-              <a:t>openstreetmap</a:t>
-            </a:r>
-            <a:r>
-              <a:rPr lang="en-GB" dirty="0">
-                <a:effectLst/>
-                <a:latin typeface="Helvetica" pitchFamily="2" charset="0"/>
-              </a:rPr>
-              <a:t> (</a:t>
-            </a:r>
-            <a:r>
-              <a:rPr lang="en-GB" dirty="0" err="1">
-                <a:effectLst/>
-                <a:latin typeface="Helvetica" pitchFamily="2" charset="0"/>
-              </a:rPr>
-              <a:t>lokal</a:t>
-            </a:r>
-            <a:r>
-              <a:rPr lang="en-GB" dirty="0">
-                <a:effectLst/>
-                <a:latin typeface="Helvetica" pitchFamily="2" charset="0"/>
-              </a:rPr>
-              <a:t>) </a:t>
-            </a:r>
-            <a:r>
-              <a:rPr lang="en-GB" dirty="0" err="1">
-                <a:effectLst/>
-                <a:latin typeface="Helvetica" pitchFamily="2" charset="0"/>
-              </a:rPr>
-              <a:t>zu</a:t>
-            </a:r>
-            <a:r>
-              <a:rPr lang="en-GB" dirty="0">
-                <a:effectLst/>
-                <a:latin typeface="Helvetica" pitchFamily="2" charset="0"/>
-              </a:rPr>
-              <a:t> </a:t>
-            </a:r>
-            <a:r>
-              <a:rPr lang="en-GB" dirty="0" err="1">
-                <a:effectLst/>
-                <a:latin typeface="Helvetica" pitchFamily="2" charset="0"/>
-              </a:rPr>
-              <a:t>visualisieren</a:t>
-            </a:r>
-            <a:endParaRPr lang="en-GB" dirty="0">
-              <a:effectLst/>
-              <a:latin typeface="Helvetica" pitchFamily="2" charset="0"/>
-            </a:endParaRPr>
-          </a:p>
-          <a:p>
-            <a:r>
-              <a:rPr lang="en-GB" dirty="0" err="1">
-                <a:effectLst/>
-                <a:latin typeface="Helvetica" pitchFamily="2" charset="0"/>
-              </a:rPr>
-              <a:t>Welche</a:t>
-            </a:r>
-            <a:r>
-              <a:rPr lang="en-GB" dirty="0">
-                <a:effectLst/>
-                <a:latin typeface="Helvetica" pitchFamily="2" charset="0"/>
-              </a:rPr>
-              <a:t> </a:t>
-            </a:r>
-            <a:r>
-              <a:rPr lang="en-GB" dirty="0" err="1">
-                <a:effectLst/>
-                <a:latin typeface="Helvetica" pitchFamily="2" charset="0"/>
-              </a:rPr>
-              <a:t>Daten</a:t>
-            </a:r>
-            <a:r>
-              <a:rPr lang="en-GB" dirty="0">
-                <a:effectLst/>
-                <a:latin typeface="Helvetica" pitchFamily="2" charset="0"/>
-              </a:rPr>
-              <a:t> </a:t>
-            </a:r>
-            <a:r>
-              <a:rPr lang="en-GB" dirty="0" err="1">
-                <a:effectLst/>
-                <a:latin typeface="Helvetica" pitchFamily="2" charset="0"/>
-              </a:rPr>
-              <a:t>könnten</a:t>
-            </a:r>
-            <a:r>
-              <a:rPr lang="en-GB" dirty="0">
-                <a:effectLst/>
-                <a:latin typeface="Helvetica" pitchFamily="2" charset="0"/>
-              </a:rPr>
-              <a:t> </a:t>
-            </a:r>
-            <a:r>
-              <a:rPr lang="en-GB" dirty="0" err="1">
-                <a:effectLst/>
-                <a:latin typeface="Helvetica" pitchFamily="2" charset="0"/>
-              </a:rPr>
-              <a:t>visualisiert</a:t>
-            </a:r>
-            <a:r>
-              <a:rPr lang="en-GB" dirty="0">
-                <a:effectLst/>
-                <a:latin typeface="Helvetica" pitchFamily="2" charset="0"/>
-              </a:rPr>
-              <a:t> </a:t>
-            </a:r>
-            <a:r>
-              <a:rPr lang="en-GB" dirty="0" err="1">
-                <a:effectLst/>
-                <a:latin typeface="Helvetica" pitchFamily="2" charset="0"/>
-              </a:rPr>
-              <a:t>werden</a:t>
-            </a:r>
-            <a:endParaRPr lang="en-GB" dirty="0">
-              <a:effectLst/>
-              <a:latin typeface="Helvetica" pitchFamily="2" charset="0"/>
-            </a:endParaRPr>
-          </a:p>
-        </p:txBody>
-      </p:sp>
-      <p:sp>
-        <p:nvSpPr>
-          <p:cNvPr id="5" name="Date Placeholder 4">
-            <a:extLst>
-              <a:ext uri="{FF2B5EF4-FFF2-40B4-BE49-F238E27FC236}">
-                <a16:creationId xmlns:a16="http://schemas.microsoft.com/office/drawing/2014/main" id="{2098A1C1-C6E3-36DB-1A7D-C511DC4678E4}"/>
+          <p:cNvPr id="2" name="Titel 1">
+            <a:extLst>
+              <a:ext uri="{FF2B5EF4-FFF2-40B4-BE49-F238E27FC236}">
+                <a16:creationId xmlns:a16="http://schemas.microsoft.com/office/drawing/2014/main" id="{D6A520D6-C392-C533-56F5-A462A04BDDFD}"/>
+              </a:ext>
+            </a:extLst>
+          </p:cNvPr>
+          <p:cNvSpPr>
+            <a:spLocks noGrp="1"/>
+          </p:cNvSpPr>
+          <p:nvPr>
+            <p:ph type="title"/>
+          </p:nvPr>
+        </p:nvSpPr>
+        <p:spPr/>
+        <p:txBody>
+          <a:bodyPr/>
+          <a:lstStyle/>
+          <a:p>
+            <a:r>
+              <a:rPr lang="de-DE" dirty="0"/>
+              <a:t>Grundlegende Ideen</a:t>
+            </a:r>
+          </a:p>
+        </p:txBody>
+      </p:sp>
+      <p:sp>
+        <p:nvSpPr>
+          <p:cNvPr id="4" name="Datumsplatzhalter 3">
+            <a:extLst>
+              <a:ext uri="{FF2B5EF4-FFF2-40B4-BE49-F238E27FC236}">
+                <a16:creationId xmlns:a16="http://schemas.microsoft.com/office/drawing/2014/main" id="{A455FE9F-B9E2-4246-F312-31B4B6FCCC84}"/>
               </a:ext>
             </a:extLst>
           </p:cNvPr>
@@ -10958,20 +11713,20 @@
           <a:bodyPr/>
           <a:lstStyle/>
           <a:p>
-            <a:fld id="{0FBC0988-905C-AB41-86EF-B70567269C0A}" type="datetime1">
+            <a:fld id="{12798F19-8D51-794B-8ACF-FCEE93C20526}" type="datetime1">
               <a:rPr lang="de-DE" smtClean="0"/>
-              <a:t>16.10.24</a:t>
+              <a:t>21.10.2024</a:t>
             </a:fld>
-            <a:endParaRPr lang="en-DE" dirty="0"/>
-          </a:p>
-        </p:txBody>
-      </p:sp>
-      <p:sp>
-        <p:nvSpPr>
-          <p:cNvPr id="6" name="Slide Number Placeholder 5">
-            <a:extLst>
-              <a:ext uri="{FF2B5EF4-FFF2-40B4-BE49-F238E27FC236}">
-                <a16:creationId xmlns:a16="http://schemas.microsoft.com/office/drawing/2014/main" id="{6FD8A319-FC07-1A9E-C96D-E7A13789C453}"/>
+            <a:endParaRPr lang="en-DE"/>
+          </a:p>
+        </p:txBody>
+      </p:sp>
+      <p:sp>
+        <p:nvSpPr>
+          <p:cNvPr id="5" name="Foliennummernplatzhalter 4">
+            <a:extLst>
+              <a:ext uri="{FF2B5EF4-FFF2-40B4-BE49-F238E27FC236}">
+                <a16:creationId xmlns:a16="http://schemas.microsoft.com/office/drawing/2014/main" id="{D36A987D-E19B-C89F-E8DF-52ACB9F8D39B}"/>
               </a:ext>
             </a:extLst>
           </p:cNvPr>
@@ -10991,14 +11746,541 @@
               <a:rPr lang="en-DE" smtClean="0"/>
               <a:t>6</a:t>
             </a:fld>
-            <a:endParaRPr lang="en-DE" dirty="0"/>
-          </a:p>
-        </p:txBody>
-      </p:sp>
+            <a:endParaRPr lang="en-DE"/>
+          </a:p>
+        </p:txBody>
+      </p:sp>
+      <p:pic>
+        <p:nvPicPr>
+          <p:cNvPr id="7" name="Grafik 6">
+            <a:extLst>
+              <a:ext uri="{FF2B5EF4-FFF2-40B4-BE49-F238E27FC236}">
+                <a16:creationId xmlns:a16="http://schemas.microsoft.com/office/drawing/2014/main" id="{E248ED73-AE3A-12B4-E7F5-0FB9040DED77}"/>
+              </a:ext>
+            </a:extLst>
+          </p:cNvPr>
+          <p:cNvPicPr>
+            <a:picLocks noChangeAspect="1"/>
+          </p:cNvPicPr>
+          <p:nvPr/>
+        </p:nvPicPr>
+        <p:blipFill>
+          <a:blip r:embed="rId2">
+            <a:extLst>
+              <a:ext uri="{28A0092B-C50C-407E-A947-70E740481C1C}">
+                <a14:useLocalDpi xmlns:a14="http://schemas.microsoft.com/office/drawing/2010/main" val="0"/>
+              </a:ext>
+            </a:extLst>
+          </a:blip>
+          <a:stretch>
+            <a:fillRect/>
+          </a:stretch>
+        </p:blipFill>
+        <p:spPr>
+          <a:xfrm>
+            <a:off x="304664" y="3043089"/>
+            <a:ext cx="2755307" cy="1795700"/>
+          </a:xfrm>
+          <a:prstGeom prst="rect">
+            <a:avLst/>
+          </a:prstGeom>
+        </p:spPr>
+      </p:pic>
+      <p:pic>
+        <p:nvPicPr>
+          <p:cNvPr id="9" name="Grafik 8">
+            <a:extLst>
+              <a:ext uri="{FF2B5EF4-FFF2-40B4-BE49-F238E27FC236}">
+                <a16:creationId xmlns:a16="http://schemas.microsoft.com/office/drawing/2014/main" id="{CECFFF25-0BCA-548D-72DD-6FC086C0E5AD}"/>
+              </a:ext>
+            </a:extLst>
+          </p:cNvPr>
+          <p:cNvPicPr>
+            <a:picLocks noChangeAspect="1"/>
+          </p:cNvPicPr>
+          <p:nvPr/>
+        </p:nvPicPr>
+        <p:blipFill>
+          <a:blip r:embed="rId3">
+            <a:extLst>
+              <a:ext uri="{28A0092B-C50C-407E-A947-70E740481C1C}">
+                <a14:useLocalDpi xmlns:a14="http://schemas.microsoft.com/office/drawing/2010/main" val="0"/>
+              </a:ext>
+            </a:extLst>
+          </a:blip>
+          <a:stretch>
+            <a:fillRect/>
+          </a:stretch>
+        </p:blipFill>
+        <p:spPr>
+          <a:xfrm>
+            <a:off x="3321632" y="2796139"/>
+            <a:ext cx="2500736" cy="2161653"/>
+          </a:xfrm>
+          <a:prstGeom prst="rect">
+            <a:avLst/>
+          </a:prstGeom>
+        </p:spPr>
+      </p:pic>
+      <p:sp>
+        <p:nvSpPr>
+          <p:cNvPr id="10" name="Textfeld 9">
+            <a:extLst>
+              <a:ext uri="{FF2B5EF4-FFF2-40B4-BE49-F238E27FC236}">
+                <a16:creationId xmlns:a16="http://schemas.microsoft.com/office/drawing/2014/main" id="{E2AE8E0B-2618-61CD-E691-60873F68D43D}"/>
+              </a:ext>
+            </a:extLst>
+          </p:cNvPr>
+          <p:cNvSpPr txBox="1"/>
+          <p:nvPr/>
+        </p:nvSpPr>
+        <p:spPr>
+          <a:xfrm>
+            <a:off x="3059971" y="3690784"/>
+            <a:ext cx="319318" cy="369332"/>
+          </a:xfrm>
+          <a:prstGeom prst="rect">
+            <a:avLst/>
+          </a:prstGeom>
+          <a:noFill/>
+        </p:spPr>
+        <p:txBody>
+          <a:bodyPr wrap="none" rtlCol="0">
+            <a:spAutoFit/>
+          </a:bodyPr>
+          <a:lstStyle/>
+          <a:p>
+            <a:r>
+              <a:rPr lang="de-DE" dirty="0"/>
+              <a:t>+</a:t>
+            </a:r>
+          </a:p>
+        </p:txBody>
+      </p:sp>
+      <p:sp>
+        <p:nvSpPr>
+          <p:cNvPr id="11" name="Textfeld 10">
+            <a:extLst>
+              <a:ext uri="{FF2B5EF4-FFF2-40B4-BE49-F238E27FC236}">
+                <a16:creationId xmlns:a16="http://schemas.microsoft.com/office/drawing/2014/main" id="{CEFD6AE5-73E0-50A0-57F0-6165C27701D0}"/>
+              </a:ext>
+            </a:extLst>
+          </p:cNvPr>
+          <p:cNvSpPr txBox="1"/>
+          <p:nvPr/>
+        </p:nvSpPr>
+        <p:spPr>
+          <a:xfrm>
+            <a:off x="6084029" y="3692299"/>
+            <a:ext cx="319318" cy="369332"/>
+          </a:xfrm>
+          <a:prstGeom prst="rect">
+            <a:avLst/>
+          </a:prstGeom>
+          <a:noFill/>
+        </p:spPr>
+        <p:txBody>
+          <a:bodyPr wrap="none" rtlCol="0">
+            <a:spAutoFit/>
+          </a:bodyPr>
+          <a:lstStyle/>
+          <a:p>
+            <a:r>
+              <a:rPr lang="de-DE" dirty="0"/>
+              <a:t>=</a:t>
+            </a:r>
+          </a:p>
+        </p:txBody>
+      </p:sp>
+      <p:pic>
+        <p:nvPicPr>
+          <p:cNvPr id="13" name="Grafik 12">
+            <a:extLst>
+              <a:ext uri="{FF2B5EF4-FFF2-40B4-BE49-F238E27FC236}">
+                <a16:creationId xmlns:a16="http://schemas.microsoft.com/office/drawing/2014/main" id="{EA8E2DEF-F122-D850-CEB4-24B92716906F}"/>
+              </a:ext>
+            </a:extLst>
+          </p:cNvPr>
+          <p:cNvPicPr>
+            <a:picLocks noChangeAspect="1"/>
+          </p:cNvPicPr>
+          <p:nvPr/>
+        </p:nvPicPr>
+        <p:blipFill>
+          <a:blip r:embed="rId4"/>
+          <a:stretch>
+            <a:fillRect/>
+          </a:stretch>
+        </p:blipFill>
+        <p:spPr>
+          <a:xfrm>
+            <a:off x="6390891" y="3165701"/>
+            <a:ext cx="2295549" cy="1501241"/>
+          </a:xfrm>
+          <a:prstGeom prst="rect">
+            <a:avLst/>
+          </a:prstGeom>
+        </p:spPr>
+      </p:pic>
     </p:spTree>
     <p:extLst>
       <p:ext uri="{BB962C8B-B14F-4D97-AF65-F5344CB8AC3E}">
-        <p14:creationId xmlns:p14="http://schemas.microsoft.com/office/powerpoint/2010/main" val="947827265"/>
+        <p14:creationId xmlns:p14="http://schemas.microsoft.com/office/powerpoint/2010/main" val="2567050617"/>
+      </p:ext>
+    </p:extLst>
+  </p:cSld>
+  <p:clrMapOvr>
+    <a:masterClrMapping/>
+  </p:clrMapOvr>
+</p:sld>
+</file>
+
+<file path=ppt/slides/slide8.xml><?xml version="1.0" encoding="utf-8"?>
+<p:sld xmlns:a="http://schemas.openxmlformats.org/drawingml/2006/main" xmlns:r="http://schemas.openxmlformats.org/officeDocument/2006/relationships" xmlns:p="http://schemas.openxmlformats.org/presentationml/2006/main">
+  <p:cSld>
+    <p:spTree>
+      <p:nvGrpSpPr>
+        <p:cNvPr id="1" name=""/>
+        <p:cNvGrpSpPr/>
+        <p:nvPr/>
+      </p:nvGrpSpPr>
+      <p:grpSpPr>
+        <a:xfrm>
+          <a:off x="0" y="0"/>
+          <a:ext cx="0" cy="0"/>
+          <a:chOff x="0" y="0"/>
+          <a:chExt cx="0" cy="0"/>
+        </a:xfrm>
+      </p:grpSpPr>
+      <p:sp>
+        <p:nvSpPr>
+          <p:cNvPr id="2" name="Titel 1">
+            <a:extLst>
+              <a:ext uri="{FF2B5EF4-FFF2-40B4-BE49-F238E27FC236}">
+                <a16:creationId xmlns:a16="http://schemas.microsoft.com/office/drawing/2014/main" id="{4F70BF27-689E-75D8-3F85-ACAB4E17F873}"/>
+              </a:ext>
+            </a:extLst>
+          </p:cNvPr>
+          <p:cNvSpPr>
+            <a:spLocks noGrp="1"/>
+          </p:cNvSpPr>
+          <p:nvPr>
+            <p:ph type="title"/>
+          </p:nvPr>
+        </p:nvSpPr>
+        <p:spPr/>
+        <p:txBody>
+          <a:bodyPr/>
+          <a:lstStyle/>
+          <a:p>
+            <a:r>
+              <a:rPr lang="de-DE" dirty="0"/>
+              <a:t>Was wir benötigen</a:t>
+            </a:r>
+          </a:p>
+        </p:txBody>
+      </p:sp>
+      <p:sp>
+        <p:nvSpPr>
+          <p:cNvPr id="3" name="Untertitel 2">
+            <a:extLst>
+              <a:ext uri="{FF2B5EF4-FFF2-40B4-BE49-F238E27FC236}">
+                <a16:creationId xmlns:a16="http://schemas.microsoft.com/office/drawing/2014/main" id="{EA3E1FAA-314F-20BC-BCC4-733F2774D76D}"/>
+              </a:ext>
+            </a:extLst>
+          </p:cNvPr>
+          <p:cNvSpPr>
+            <a:spLocks noGrp="1"/>
+          </p:cNvSpPr>
+          <p:nvPr>
+            <p:ph type="subTitle"/>
+          </p:nvPr>
+        </p:nvSpPr>
+        <p:spPr/>
+        <p:txBody>
+          <a:bodyPr/>
+          <a:lstStyle/>
+          <a:p>
+            <a:r>
+              <a:rPr lang="de-DE" dirty="0"/>
+              <a:t>Vektordarstellung (gerichtet) der Straßen Hamburgs</a:t>
+            </a:r>
+          </a:p>
+          <a:p>
+            <a:r>
+              <a:rPr lang="de-DE" dirty="0"/>
+              <a:t>Approximative Wartezeit je Ampel an einer Straße</a:t>
+            </a:r>
+          </a:p>
+          <a:p>
+            <a:pPr lvl="1"/>
+            <a:r>
+              <a:rPr lang="de-DE" dirty="0"/>
+              <a:t>Oder nur Daten Cluster</a:t>
+            </a:r>
+          </a:p>
+          <a:p>
+            <a:r>
+              <a:rPr lang="de-DE" dirty="0"/>
+              <a:t>Anforderung von Frontend für die Schnittstelle</a:t>
+            </a:r>
+          </a:p>
+        </p:txBody>
+      </p:sp>
+      <p:sp>
+        <p:nvSpPr>
+          <p:cNvPr id="4" name="Datumsplatzhalter 3">
+            <a:extLst>
+              <a:ext uri="{FF2B5EF4-FFF2-40B4-BE49-F238E27FC236}">
+                <a16:creationId xmlns:a16="http://schemas.microsoft.com/office/drawing/2014/main" id="{36E02DA5-06A2-6673-9853-1D2FC28F77FD}"/>
+              </a:ext>
+            </a:extLst>
+          </p:cNvPr>
+          <p:cNvSpPr>
+            <a:spLocks noGrp="1"/>
+          </p:cNvSpPr>
+          <p:nvPr>
+            <p:ph type="dt" sz="half" idx="10"/>
+          </p:nvPr>
+        </p:nvSpPr>
+        <p:spPr/>
+        <p:txBody>
+          <a:bodyPr/>
+          <a:lstStyle/>
+          <a:p>
+            <a:fld id="{12798F19-8D51-794B-8ACF-FCEE93C20526}" type="datetime1">
+              <a:rPr lang="de-DE" smtClean="0"/>
+              <a:t>21.10.2024</a:t>
+            </a:fld>
+            <a:endParaRPr lang="en-DE"/>
+          </a:p>
+        </p:txBody>
+      </p:sp>
+      <p:sp>
+        <p:nvSpPr>
+          <p:cNvPr id="5" name="Foliennummernplatzhalter 4">
+            <a:extLst>
+              <a:ext uri="{FF2B5EF4-FFF2-40B4-BE49-F238E27FC236}">
+                <a16:creationId xmlns:a16="http://schemas.microsoft.com/office/drawing/2014/main" id="{493F16DB-379B-5BCE-AE78-4195E65D4A91}"/>
+              </a:ext>
+            </a:extLst>
+          </p:cNvPr>
+          <p:cNvSpPr>
+            <a:spLocks noGrp="1"/>
+          </p:cNvSpPr>
+          <p:nvPr>
+            <p:ph type="sldNum" sz="quarter" idx="12"/>
+          </p:nvPr>
+        </p:nvSpPr>
+        <p:spPr/>
+        <p:txBody>
+          <a:bodyPr/>
+          <a:lstStyle/>
+          <a:p>
+            <a:fld id="{1148E9C0-692D-B340-AF6F-432654B065A1}" type="slidenum">
+              <a:rPr lang="en-DE" smtClean="0"/>
+              <a:t>7</a:t>
+            </a:fld>
+            <a:endParaRPr lang="en-DE"/>
+          </a:p>
+        </p:txBody>
+      </p:sp>
+    </p:spTree>
+    <p:extLst>
+      <p:ext uri="{BB962C8B-B14F-4D97-AF65-F5344CB8AC3E}">
+        <p14:creationId xmlns:p14="http://schemas.microsoft.com/office/powerpoint/2010/main" val="3853894730"/>
+      </p:ext>
+    </p:extLst>
+  </p:cSld>
+  <p:clrMapOvr>
+    <a:masterClrMapping/>
+  </p:clrMapOvr>
+</p:sld>
+</file>
+
+<file path=ppt/slides/slide9.xml><?xml version="1.0" encoding="utf-8"?>
+<p:sld xmlns:a="http://schemas.openxmlformats.org/drawingml/2006/main" xmlns:r="http://schemas.openxmlformats.org/officeDocument/2006/relationships" xmlns:p="http://schemas.openxmlformats.org/presentationml/2006/main">
+  <p:cSld>
+    <p:spTree>
+      <p:nvGrpSpPr>
+        <p:cNvPr id="1" name=""/>
+        <p:cNvGrpSpPr/>
+        <p:nvPr/>
+      </p:nvGrpSpPr>
+      <p:grpSpPr>
+        <a:xfrm>
+          <a:off x="0" y="0"/>
+          <a:ext cx="0" cy="0"/>
+          <a:chOff x="0" y="0"/>
+          <a:chExt cx="0" cy="0"/>
+        </a:xfrm>
+      </p:grpSpPr>
+      <p:sp>
+        <p:nvSpPr>
+          <p:cNvPr id="2" name="Titel 1">
+            <a:extLst>
+              <a:ext uri="{FF2B5EF4-FFF2-40B4-BE49-F238E27FC236}">
+                <a16:creationId xmlns:a16="http://schemas.microsoft.com/office/drawing/2014/main" id="{C546E525-69D0-15CC-D76B-0C881277DEFC}"/>
+              </a:ext>
+            </a:extLst>
+          </p:cNvPr>
+          <p:cNvSpPr>
+            <a:spLocks noGrp="1"/>
+          </p:cNvSpPr>
+          <p:nvPr>
+            <p:ph type="title"/>
+          </p:nvPr>
+        </p:nvSpPr>
+        <p:spPr/>
+        <p:txBody>
+          <a:bodyPr/>
+          <a:lstStyle/>
+          <a:p>
+            <a:r>
+              <a:rPr lang="de-DE" dirty="0"/>
+              <a:t>Welche Funktion soll das </a:t>
+            </a:r>
+            <a:r>
+              <a:rPr lang="de-DE" dirty="0" err="1"/>
+              <a:t>Program</a:t>
+            </a:r>
+            <a:r>
+              <a:rPr lang="de-DE" dirty="0"/>
+              <a:t> haben?</a:t>
+            </a:r>
+          </a:p>
+        </p:txBody>
+      </p:sp>
+      <p:sp>
+        <p:nvSpPr>
+          <p:cNvPr id="3" name="Untertitel 2">
+            <a:extLst>
+              <a:ext uri="{FF2B5EF4-FFF2-40B4-BE49-F238E27FC236}">
+                <a16:creationId xmlns:a16="http://schemas.microsoft.com/office/drawing/2014/main" id="{513FE101-2909-EEFC-D29F-EFEBBB46CF9C}"/>
+              </a:ext>
+            </a:extLst>
+          </p:cNvPr>
+          <p:cNvSpPr>
+            <a:spLocks noGrp="1"/>
+          </p:cNvSpPr>
+          <p:nvPr>
+            <p:ph type="subTitle"/>
+          </p:nvPr>
+        </p:nvSpPr>
+        <p:spPr/>
+        <p:txBody>
+          <a:bodyPr/>
+          <a:lstStyle/>
+          <a:p>
+            <a:r>
+              <a:rPr lang="de-DE" dirty="0"/>
+              <a:t>Ebene 0.</a:t>
+            </a:r>
+          </a:p>
+          <a:p>
+            <a:pPr lvl="1"/>
+            <a:r>
+              <a:rPr lang="de-DE" dirty="0"/>
+              <a:t>Zuordnen und mappen der Ampel auf entsprechende Vektordarstellung.</a:t>
+            </a:r>
+          </a:p>
+          <a:p>
+            <a:r>
+              <a:rPr lang="de-DE" dirty="0"/>
+              <a:t>Ebene 1.</a:t>
+            </a:r>
+          </a:p>
+          <a:p>
+            <a:pPr lvl="1"/>
+            <a:r>
+              <a:rPr lang="de-DE" dirty="0"/>
+              <a:t>Generische Angabe einer approximierten Fahrzeit</a:t>
+            </a:r>
+          </a:p>
+          <a:p>
+            <a:pPr lvl="1"/>
+            <a:r>
+              <a:rPr lang="de-DE" dirty="0"/>
+              <a:t>Approximierte benötigte Durchschnittsgeschwindigkeit pro Straßenabschnitt</a:t>
+            </a:r>
+          </a:p>
+          <a:p>
+            <a:r>
+              <a:rPr lang="de-DE" dirty="0"/>
+              <a:t>Ebene 2.</a:t>
+            </a:r>
+          </a:p>
+          <a:p>
+            <a:pPr lvl="1"/>
+            <a:r>
+              <a:rPr lang="de-DE" dirty="0"/>
+              <a:t>Echtzeit Anpassung und Implementierung von Schaltung und Betätigung von Ampeln</a:t>
+            </a:r>
+          </a:p>
+        </p:txBody>
+      </p:sp>
+      <p:sp>
+        <p:nvSpPr>
+          <p:cNvPr id="4" name="Datumsplatzhalter 3">
+            <a:extLst>
+              <a:ext uri="{FF2B5EF4-FFF2-40B4-BE49-F238E27FC236}">
+                <a16:creationId xmlns:a16="http://schemas.microsoft.com/office/drawing/2014/main" id="{303ED6E9-0D78-B7F4-E7EF-253A3CDC1105}"/>
+              </a:ext>
+            </a:extLst>
+          </p:cNvPr>
+          <p:cNvSpPr>
+            <a:spLocks noGrp="1"/>
+          </p:cNvSpPr>
+          <p:nvPr>
+            <p:ph type="dt" sz="half" idx="10"/>
+          </p:nvPr>
+        </p:nvSpPr>
+        <p:spPr/>
+        <p:txBody>
+          <a:bodyPr/>
+          <a:lstStyle/>
+          <a:p>
+            <a:fld id="{12798F19-8D51-794B-8ACF-FCEE93C20526}" type="datetime1">
+              <a:rPr lang="de-DE" smtClean="0"/>
+              <a:t>21.10.2024</a:t>
+            </a:fld>
+            <a:endParaRPr lang="en-DE"/>
+          </a:p>
+        </p:txBody>
+      </p:sp>
+      <p:sp>
+        <p:nvSpPr>
+          <p:cNvPr id="5" name="Foliennummernplatzhalter 4">
+            <a:extLst>
+              <a:ext uri="{FF2B5EF4-FFF2-40B4-BE49-F238E27FC236}">
+                <a16:creationId xmlns:a16="http://schemas.microsoft.com/office/drawing/2014/main" id="{D3809B23-3B28-6BC5-EE28-E419C0973495}"/>
+              </a:ext>
+            </a:extLst>
+          </p:cNvPr>
+          <p:cNvSpPr>
+            <a:spLocks noGrp="1"/>
+          </p:cNvSpPr>
+          <p:nvPr>
+            <p:ph type="sldNum" sz="quarter" idx="12"/>
+          </p:nvPr>
+        </p:nvSpPr>
+        <p:spPr/>
+        <p:txBody>
+          <a:bodyPr/>
+          <a:lstStyle/>
+          <a:p>
+            <a:fld id="{1148E9C0-692D-B340-AF6F-432654B065A1}" type="slidenum">
+              <a:rPr lang="en-DE" smtClean="0"/>
+              <a:t>8</a:t>
+            </a:fld>
+            <a:endParaRPr lang="en-DE"/>
+          </a:p>
+        </p:txBody>
+      </p:sp>
+    </p:spTree>
+    <p:extLst>
+      <p:ext uri="{BB962C8B-B14F-4D97-AF65-F5344CB8AC3E}">
+        <p14:creationId xmlns:p14="http://schemas.microsoft.com/office/powerpoint/2010/main" val="2973953001"/>
       </p:ext>
     </p:extLst>
   </p:cSld>

</xml_diff>

<commit_message>
Frontend ergänzt in Powerpoint
</commit_message>
<xml_diff>
--- a/CiS-Projekt.pptx
+++ b/CiS-Projekt.pptx
@@ -6,10 +6,10 @@
     <p:sldMasterId id="2147483661" r:id="rId2"/>
   </p:sldMasterIdLst>
   <p:notesMasterIdLst>
-    <p:notesMasterId r:id="rId16"/>
+    <p:notesMasterId r:id="rId17"/>
   </p:notesMasterIdLst>
   <p:handoutMasterIdLst>
-    <p:handoutMasterId r:id="rId17"/>
+    <p:handoutMasterId r:id="rId18"/>
   </p:handoutMasterIdLst>
   <p:sldIdLst>
     <p:sldId id="256" r:id="rId3"/>
@@ -24,7 +24,8 @@
     <p:sldId id="266" r:id="rId12"/>
     <p:sldId id="267" r:id="rId13"/>
     <p:sldId id="268" r:id="rId14"/>
-    <p:sldId id="262" r:id="rId15"/>
+    <p:sldId id="269" r:id="rId15"/>
+    <p:sldId id="270" r:id="rId16"/>
   </p:sldIdLst>
   <p:sldSz cx="9144000" cy="6858000" type="screen4x3"/>
   <p:notesSz cx="7772400" cy="10058400"/>
@@ -228,7 +229,7 @@
           <a:p>
             <a:fld id="{77AB800C-305E-2C41-8096-0EDBE764B1AF}" type="datetimeFigureOut">
               <a:rPr lang="en-DE" smtClean="0"/>
-              <a:t>10/21/2024</a:t>
+              <a:t>10/22/24</a:t>
             </a:fld>
             <a:endParaRPr lang="en-DE"/>
           </a:p>
@@ -405,7 +406,7 @@
           <a:p>
             <a:fld id="{502A31B7-B52A-AE43-A408-51D438091011}" type="datetimeFigureOut">
               <a:rPr lang="en-DE" smtClean="0"/>
-              <a:t>10/21/2024</a:t>
+              <a:t>10/22/24</a:t>
             </a:fld>
             <a:endParaRPr lang="en-DE"/>
           </a:p>
@@ -713,7 +714,7 @@
           <a:p>
             <a:fld id="{87EC9D13-9386-5F42-819D-64F68B7EC33E}" type="datetime1">
               <a:rPr lang="de-DE" smtClean="0"/>
-              <a:t>21.10.2024</a:t>
+              <a:t>22.10.24</a:t>
             </a:fld>
             <a:endParaRPr lang="en-DE"/>
           </a:p>
@@ -938,7 +939,7 @@
           <a:p>
             <a:fld id="{527A4C91-0AAD-D347-8A12-A61F0BD423D4}" type="datetime1">
               <a:rPr lang="de-DE" smtClean="0"/>
-              <a:t>21.10.2024</a:t>
+              <a:t>22.10.24</a:t>
             </a:fld>
             <a:endParaRPr lang="en-DE"/>
           </a:p>
@@ -1239,7 +1240,7 @@
           <a:p>
             <a:fld id="{4522998C-E1D0-3948-9C4C-A4844208B326}" type="datetime1">
               <a:rPr lang="de-DE" smtClean="0"/>
-              <a:t>21.10.2024</a:t>
+              <a:t>22.10.24</a:t>
             </a:fld>
             <a:endParaRPr lang="en-DE"/>
           </a:p>
@@ -1616,7 +1617,7 @@
           <a:p>
             <a:fld id="{44DC767A-87D7-8847-8135-03DC509387E7}" type="datetime1">
               <a:rPr lang="de-DE" smtClean="0"/>
-              <a:t>21.10.2024</a:t>
+              <a:t>22.10.24</a:t>
             </a:fld>
             <a:endParaRPr lang="en-DE"/>
           </a:p>
@@ -1724,7 +1725,7 @@
           <a:p>
             <a:fld id="{EA779ABD-E509-A24E-B468-A7395207E925}" type="datetime1">
               <a:rPr lang="de-DE" smtClean="0"/>
-              <a:t>21.10.2024</a:t>
+              <a:t>22.10.24</a:t>
             </a:fld>
             <a:endParaRPr lang="en-DE" dirty="0"/>
           </a:p>
@@ -1914,7 +1915,7 @@
           <a:p>
             <a:fld id="{12798F19-8D51-794B-8ACF-FCEE93C20526}" type="datetime1">
               <a:rPr lang="de-DE" smtClean="0"/>
-              <a:t>21.10.2024</a:t>
+              <a:t>22.10.24</a:t>
             </a:fld>
             <a:endParaRPr lang="en-DE"/>
           </a:p>
@@ -2101,7 +2102,7 @@
           <a:p>
             <a:fld id="{5E82FD34-7F6C-EC46-AEB1-845633BA5368}" type="datetime1">
               <a:rPr lang="de-DE" smtClean="0"/>
-              <a:t>21.10.2024</a:t>
+              <a:t>22.10.24</a:t>
             </a:fld>
             <a:endParaRPr lang="en-DE"/>
           </a:p>
@@ -2326,7 +2327,7 @@
           <a:p>
             <a:fld id="{CB9D10AC-CF20-B944-9D9D-D70D31AC71E3}" type="datetime1">
               <a:rPr lang="de-DE" smtClean="0"/>
-              <a:t>21.10.2024</a:t>
+              <a:t>22.10.24</a:t>
             </a:fld>
             <a:endParaRPr lang="en-DE"/>
           </a:p>
@@ -2475,7 +2476,7 @@
           <a:p>
             <a:fld id="{849E575B-8C89-5A46-A500-EEE867877C68}" type="datetime1">
               <a:rPr lang="de-DE" smtClean="0"/>
-              <a:t>21.10.2024</a:t>
+              <a:t>22.10.24</a:t>
             </a:fld>
             <a:endParaRPr lang="en-DE"/>
           </a:p>
@@ -2624,7 +2625,7 @@
           <a:p>
             <a:fld id="{74293AA7-5923-6A4D-8C54-7BAA40441436}" type="datetime1">
               <a:rPr lang="de-DE" smtClean="0"/>
-              <a:t>21.10.2024</a:t>
+              <a:t>22.10.24</a:t>
             </a:fld>
             <a:endParaRPr lang="en-DE"/>
           </a:p>
@@ -2887,7 +2888,7 @@
           <a:p>
             <a:fld id="{BB4820AA-6151-0C4C-B826-4FC62DBABCAE}" type="datetime1">
               <a:rPr lang="de-DE" smtClean="0"/>
-              <a:t>21.10.2024</a:t>
+              <a:t>22.10.24</a:t>
             </a:fld>
             <a:endParaRPr lang="en-DE"/>
           </a:p>
@@ -3077,7 +3078,7 @@
           <a:p>
             <a:fld id="{8FB64747-FE93-C348-B38C-977650B50862}" type="datetime1">
               <a:rPr lang="de-DE" smtClean="0"/>
-              <a:t>21.10.2024</a:t>
+              <a:t>22.10.24</a:t>
             </a:fld>
             <a:endParaRPr lang="en-DE"/>
           </a:p>
@@ -3340,7 +3341,7 @@
           <a:p>
             <a:fld id="{64004B49-DE67-A942-A928-C596320198E2}" type="datetime1">
               <a:rPr lang="de-DE" smtClean="0"/>
-              <a:t>21.10.2024</a:t>
+              <a:t>22.10.24</a:t>
             </a:fld>
             <a:endParaRPr lang="en-DE"/>
           </a:p>
@@ -3603,7 +3604,7 @@
           <a:p>
             <a:fld id="{C7C9E177-A04B-2144-839B-78BA09DD5A4B}" type="datetime1">
               <a:rPr lang="de-DE" smtClean="0"/>
-              <a:t>21.10.2024</a:t>
+              <a:t>22.10.24</a:t>
             </a:fld>
             <a:endParaRPr lang="en-DE"/>
           </a:p>
@@ -3828,7 +3829,7 @@
           <a:p>
             <a:fld id="{4989E16C-ECE5-A24A-BE33-2A36DC0B5546}" type="datetime1">
               <a:rPr lang="de-DE" smtClean="0"/>
-              <a:t>21.10.2024</a:t>
+              <a:t>22.10.24</a:t>
             </a:fld>
             <a:endParaRPr lang="en-DE"/>
           </a:p>
@@ -4129,7 +4130,7 @@
           <a:p>
             <a:fld id="{3513ED3D-829E-C84D-A902-4B819A54677D}" type="datetime1">
               <a:rPr lang="de-DE" smtClean="0"/>
-              <a:t>21.10.2024</a:t>
+              <a:t>22.10.24</a:t>
             </a:fld>
             <a:endParaRPr lang="en-DE"/>
           </a:p>
@@ -4506,7 +4507,7 @@
           <a:p>
             <a:fld id="{3212F563-1640-9541-9315-7D892C0CA96C}" type="datetime1">
               <a:rPr lang="de-DE" smtClean="0"/>
-              <a:t>21.10.2024</a:t>
+              <a:t>22.10.24</a:t>
             </a:fld>
             <a:endParaRPr lang="en-DE"/>
           </a:p>
@@ -4693,7 +4694,7 @@
           <a:p>
             <a:fld id="{3AA625C0-B810-4042-A60B-CD0C68D4A602}" type="datetime1">
               <a:rPr lang="de-DE" smtClean="0"/>
-              <a:t>21.10.2024</a:t>
+              <a:t>22.10.24</a:t>
             </a:fld>
             <a:endParaRPr lang="en-DE"/>
           </a:p>
@@ -4918,7 +4919,7 @@
           <a:p>
             <a:fld id="{459B706D-46CB-4945-98A8-83DD4363C0CC}" type="datetime1">
               <a:rPr lang="de-DE" smtClean="0"/>
-              <a:t>21.10.2024</a:t>
+              <a:t>22.10.24</a:t>
             </a:fld>
             <a:endParaRPr lang="en-DE"/>
           </a:p>
@@ -5067,7 +5068,7 @@
           <a:p>
             <a:fld id="{453998D7-97AC-4645-9850-2BABD1A4FF50}" type="datetime1">
               <a:rPr lang="de-DE" smtClean="0"/>
-              <a:t>21.10.2024</a:t>
+              <a:t>22.10.24</a:t>
             </a:fld>
             <a:endParaRPr lang="en-DE"/>
           </a:p>
@@ -5216,7 +5217,7 @@
           <a:p>
             <a:fld id="{16ADEC65-F8A2-6743-8A16-0664123CA582}" type="datetime1">
               <a:rPr lang="de-DE" smtClean="0"/>
-              <a:t>21.10.2024</a:t>
+              <a:t>22.10.24</a:t>
             </a:fld>
             <a:endParaRPr lang="en-DE"/>
           </a:p>
@@ -5479,7 +5480,7 @@
           <a:p>
             <a:fld id="{CEF5A2FE-F587-8945-B5BB-F8F2B9389C3F}" type="datetime1">
               <a:rPr lang="de-DE" smtClean="0"/>
-              <a:t>21.10.2024</a:t>
+              <a:t>22.10.24</a:t>
             </a:fld>
             <a:endParaRPr lang="en-DE"/>
           </a:p>
@@ -5742,7 +5743,7 @@
           <a:p>
             <a:fld id="{A79FFF01-31BB-1349-904F-CC2DBF738C7D}" type="datetime1">
               <a:rPr lang="de-DE" smtClean="0"/>
-              <a:t>21.10.2024</a:t>
+              <a:t>22.10.24</a:t>
             </a:fld>
             <a:endParaRPr lang="en-DE"/>
           </a:p>
@@ -6005,7 +6006,7 @@
           <a:p>
             <a:fld id="{A671271C-13EF-A14D-AEBE-C2523EB58D17}" type="datetime1">
               <a:rPr lang="de-DE" smtClean="0"/>
-              <a:t>21.10.2024</a:t>
+              <a:t>22.10.24</a:t>
             </a:fld>
             <a:endParaRPr lang="en-DE"/>
           </a:p>
@@ -6934,7 +6935,7 @@
           <a:p>
             <a:fld id="{3787732F-142C-AC47-B643-19D1499432B7}" type="datetime1">
               <a:rPr lang="de-DE" smtClean="0"/>
-              <a:t>21.10.2024</a:t>
+              <a:t>22.10.24</a:t>
             </a:fld>
             <a:endParaRPr lang="en-DE"/>
           </a:p>
@@ -7991,7 +7992,7 @@
           <a:p>
             <a:fld id="{DEA6639B-6ECB-1F4C-A239-3D3843A9EA7B}" type="datetime1">
               <a:rPr lang="de-DE" smtClean="0"/>
-              <a:t>21.10.2024</a:t>
+              <a:t>22.10.24</a:t>
             </a:fld>
             <a:endParaRPr lang="en-DE"/>
           </a:p>
@@ -8725,7 +8726,7 @@
           <a:p>
             <a:fld id="{12798F19-8D51-794B-8ACF-FCEE93C20526}" type="datetime1">
               <a:rPr lang="de-DE" smtClean="0"/>
-              <a:t>21.10.2024</a:t>
+              <a:t>22.10.24</a:t>
             </a:fld>
             <a:endParaRPr lang="en-DE"/>
           </a:p>
@@ -8841,7 +8842,7 @@
           <a:p>
             <a:fld id="{12798F19-8D51-794B-8ACF-FCEE93C20526}" type="datetime1">
               <a:rPr lang="de-DE" smtClean="0"/>
-              <a:t>21.10.2024</a:t>
+              <a:t>22.10.24</a:t>
             </a:fld>
             <a:endParaRPr lang="en-DE"/>
           </a:p>
@@ -8987,7 +8988,7 @@
           <a:p>
             <a:fld id="{12798F19-8D51-794B-8ACF-FCEE93C20526}" type="datetime1">
               <a:rPr lang="de-DE" smtClean="0"/>
-              <a:t>21.10.2024</a:t>
+              <a:t>22.10.24</a:t>
             </a:fld>
             <a:endParaRPr lang="en-DE"/>
           </a:p>
@@ -9164,8 +9165,8 @@
         </p:nvSpPr>
         <p:spPr>
           <a:xfrm>
-            <a:off x="457200" y="1682496"/>
-            <a:ext cx="6833616" cy="646331"/>
+            <a:off x="315685" y="1257953"/>
+            <a:ext cx="6833616" cy="1477328"/>
           </a:xfrm>
           <a:prstGeom prst="rect">
             <a:avLst/>
@@ -9183,7 +9184,7 @@
                 <a:effectLst/>
                 <a:latin typeface="Helvetica" pitchFamily="2" charset="0"/>
               </a:rPr>
-              <a:t>Möglichkeiten</a:t>
+              <a:t>Möglichkeit</a:t>
             </a:r>
             <a:r>
               <a:rPr lang="en-GB" dirty="0">
@@ -9241,75 +9242,42 @@
               </a:rPr>
               <a:t>visualisieren</a:t>
             </a:r>
+            <a:r>
+              <a:rPr lang="en-GB" dirty="0">
+                <a:effectLst/>
+                <a:latin typeface="Helvetica" pitchFamily="2" charset="0"/>
+              </a:rPr>
+              <a:t>:</a:t>
+            </a:r>
+          </a:p>
+          <a:p>
+            <a:endParaRPr lang="en-GB" dirty="0">
+              <a:latin typeface="Helvetica" pitchFamily="2" charset="0"/>
+            </a:endParaRPr>
+          </a:p>
+          <a:p>
+            <a:pPr marL="285750" indent="-285750">
+              <a:buFont typeface="Arial" panose="020B0604020202020204" pitchFamily="34" charset="0"/>
+              <a:buChar char="•"/>
+            </a:pPr>
+            <a:r>
+              <a:rPr lang="en-GB" dirty="0">
+                <a:latin typeface="Helvetica" pitchFamily="2" charset="0"/>
+              </a:rPr>
+              <a:t>Dash Leaflet</a:t>
+            </a:r>
+          </a:p>
+          <a:p>
+            <a:pPr marL="285750" indent="-285750">
+              <a:buFont typeface="Arial" panose="020B0604020202020204" pitchFamily="34" charset="0"/>
+              <a:buChar char="•"/>
+            </a:pPr>
             <a:endParaRPr lang="en-GB" dirty="0">
               <a:effectLst/>
               <a:latin typeface="Helvetica" pitchFamily="2" charset="0"/>
             </a:endParaRPr>
           </a:p>
           <a:p>
-            <a:r>
-              <a:rPr lang="en-GB" dirty="0" err="1">
-                <a:effectLst/>
-                <a:latin typeface="Helvetica" pitchFamily="2" charset="0"/>
-              </a:rPr>
-              <a:t>Welche</a:t>
-            </a:r>
-            <a:r>
-              <a:rPr lang="en-GB" dirty="0">
-                <a:effectLst/>
-                <a:latin typeface="Helvetica" pitchFamily="2" charset="0"/>
-              </a:rPr>
-              <a:t> </a:t>
-            </a:r>
-            <a:r>
-              <a:rPr lang="en-GB" dirty="0" err="1">
-                <a:effectLst/>
-                <a:latin typeface="Helvetica" pitchFamily="2" charset="0"/>
-              </a:rPr>
-              <a:t>Daten</a:t>
-            </a:r>
-            <a:r>
-              <a:rPr lang="en-GB" dirty="0">
-                <a:effectLst/>
-                <a:latin typeface="Helvetica" pitchFamily="2" charset="0"/>
-              </a:rPr>
-              <a:t> </a:t>
-            </a:r>
-            <a:r>
-              <a:rPr lang="en-GB" dirty="0" err="1">
-                <a:effectLst/>
-                <a:latin typeface="Helvetica" pitchFamily="2" charset="0"/>
-              </a:rPr>
-              <a:t>könnten</a:t>
-            </a:r>
-            <a:r>
-              <a:rPr lang="en-GB" dirty="0">
-                <a:effectLst/>
-                <a:latin typeface="Helvetica" pitchFamily="2" charset="0"/>
-              </a:rPr>
-              <a:t> </a:t>
-            </a:r>
-            <a:r>
-              <a:rPr lang="en-GB" dirty="0" err="1">
-                <a:effectLst/>
-                <a:latin typeface="Helvetica" pitchFamily="2" charset="0"/>
-              </a:rPr>
-              <a:t>visualisiert</a:t>
-            </a:r>
-            <a:r>
-              <a:rPr lang="en-GB" dirty="0">
-                <a:effectLst/>
-                <a:latin typeface="Helvetica" pitchFamily="2" charset="0"/>
-              </a:rPr>
-              <a:t> </a:t>
-            </a:r>
-            <a:r>
-              <a:rPr lang="en-GB" dirty="0" err="1">
-                <a:effectLst/>
-                <a:latin typeface="Helvetica" pitchFamily="2" charset="0"/>
-              </a:rPr>
-              <a:t>werden</a:t>
-            </a:r>
             <a:endParaRPr lang="en-GB" dirty="0">
               <a:effectLst/>
               <a:latin typeface="Helvetica" pitchFamily="2" charset="0"/>
@@ -9340,7 +9308,7 @@
           <a:p>
             <a:fld id="{0FBC0988-905C-AB41-86EF-B70567269C0A}" type="datetime1">
               <a:rPr lang="de-DE" smtClean="0"/>
-              <a:t>21.10.2024</a:t>
+              <a:t>22.10.24</a:t>
             </a:fld>
             <a:endParaRPr lang="en-DE" dirty="0"/>
           </a:p>
@@ -9375,10 +9343,632 @@
           </a:p>
         </p:txBody>
       </p:sp>
+      <p:pic>
+        <p:nvPicPr>
+          <p:cNvPr id="4" name="Grafik 3">
+            <a:extLst>
+              <a:ext uri="{FF2B5EF4-FFF2-40B4-BE49-F238E27FC236}">
+                <a16:creationId xmlns:a16="http://schemas.microsoft.com/office/drawing/2014/main" id="{F5263E0A-412E-3C4F-B582-C901BC801218}"/>
+              </a:ext>
+            </a:extLst>
+          </p:cNvPr>
+          <p:cNvPicPr>
+            <a:picLocks noChangeAspect="1"/>
+          </p:cNvPicPr>
+          <p:nvPr/>
+        </p:nvPicPr>
+        <p:blipFill>
+          <a:blip r:embed="rId2">
+            <a:extLst>
+              <a:ext uri="{28A0092B-C50C-407E-A947-70E740481C1C}">
+                <a14:useLocalDpi xmlns:a14="http://schemas.microsoft.com/office/drawing/2010/main" val="0"/>
+              </a:ext>
+            </a:extLst>
+          </a:blip>
+          <a:stretch>
+            <a:fillRect/>
+          </a:stretch>
+        </p:blipFill>
+        <p:spPr>
+          <a:xfrm>
+            <a:off x="177800" y="2101850"/>
+            <a:ext cx="8966200" cy="4254500"/>
+          </a:xfrm>
+          <a:prstGeom prst="rect">
+            <a:avLst/>
+          </a:prstGeom>
+        </p:spPr>
+      </p:pic>
     </p:spTree>
     <p:extLst>
       <p:ext uri="{BB962C8B-B14F-4D97-AF65-F5344CB8AC3E}">
-        <p14:creationId xmlns:p14="http://schemas.microsoft.com/office/powerpoint/2010/main" val="947827265"/>
+        <p14:creationId xmlns:p14="http://schemas.microsoft.com/office/powerpoint/2010/main" val="2956802649"/>
+      </p:ext>
+    </p:extLst>
+  </p:cSld>
+  <p:clrMapOvr>
+    <a:masterClrMapping/>
+  </p:clrMapOvr>
+</p:sld>
+</file>
+
+<file path=ppt/slides/slide14.xml><?xml version="1.0" encoding="utf-8"?>
+<p:sld xmlns:a="http://schemas.openxmlformats.org/drawingml/2006/main" xmlns:r="http://schemas.openxmlformats.org/officeDocument/2006/relationships" xmlns:p="http://schemas.openxmlformats.org/presentationml/2006/main">
+  <p:cSld>
+    <p:spTree>
+      <p:nvGrpSpPr>
+        <p:cNvPr id="1" name=""/>
+        <p:cNvGrpSpPr/>
+        <p:nvPr/>
+      </p:nvGrpSpPr>
+      <p:grpSpPr>
+        <a:xfrm>
+          <a:off x="0" y="0"/>
+          <a:ext cx="0" cy="0"/>
+          <a:chOff x="0" y="0"/>
+          <a:chExt cx="0" cy="0"/>
+        </a:xfrm>
+      </p:grpSpPr>
+      <p:sp>
+        <p:nvSpPr>
+          <p:cNvPr id="4" name="Datumsplatzhalter 3">
+            <a:extLst>
+              <a:ext uri="{FF2B5EF4-FFF2-40B4-BE49-F238E27FC236}">
+                <a16:creationId xmlns:a16="http://schemas.microsoft.com/office/drawing/2014/main" id="{AE0A2175-6F92-4C48-9E56-48E77A34904F}"/>
+              </a:ext>
+            </a:extLst>
+          </p:cNvPr>
+          <p:cNvSpPr>
+            <a:spLocks noGrp="1"/>
+          </p:cNvSpPr>
+          <p:nvPr>
+            <p:ph type="dt" sz="half" idx="10"/>
+          </p:nvPr>
+        </p:nvSpPr>
+        <p:spPr/>
+        <p:txBody>
+          <a:bodyPr/>
+          <a:lstStyle/>
+          <a:p>
+            <a:fld id="{12798F19-8D51-794B-8ACF-FCEE93C20526}" type="datetime1">
+              <a:rPr lang="de-DE" smtClean="0"/>
+              <a:t>22.10.24</a:t>
+            </a:fld>
+            <a:endParaRPr lang="en-DE"/>
+          </a:p>
+        </p:txBody>
+      </p:sp>
+      <p:sp>
+        <p:nvSpPr>
+          <p:cNvPr id="5" name="Foliennummernplatzhalter 4">
+            <a:extLst>
+              <a:ext uri="{FF2B5EF4-FFF2-40B4-BE49-F238E27FC236}">
+                <a16:creationId xmlns:a16="http://schemas.microsoft.com/office/drawing/2014/main" id="{027DB8E8-EED7-FB44-AE82-294C967D49B2}"/>
+              </a:ext>
+            </a:extLst>
+          </p:cNvPr>
+          <p:cNvSpPr>
+            <a:spLocks noGrp="1"/>
+          </p:cNvSpPr>
+          <p:nvPr>
+            <p:ph type="sldNum" sz="quarter" idx="12"/>
+          </p:nvPr>
+        </p:nvSpPr>
+        <p:spPr/>
+        <p:txBody>
+          <a:bodyPr/>
+          <a:lstStyle/>
+          <a:p>
+            <a:fld id="{1148E9C0-692D-B340-AF6F-432654B065A1}" type="slidenum">
+              <a:rPr lang="en-DE" smtClean="0"/>
+              <a:t>13</a:t>
+            </a:fld>
+            <a:endParaRPr lang="en-DE"/>
+          </a:p>
+        </p:txBody>
+      </p:sp>
+      <p:sp>
+        <p:nvSpPr>
+          <p:cNvPr id="6" name="TextBox 1">
+            <a:extLst>
+              <a:ext uri="{FF2B5EF4-FFF2-40B4-BE49-F238E27FC236}">
+                <a16:creationId xmlns:a16="http://schemas.microsoft.com/office/drawing/2014/main" id="{D6AEF025-CA2B-214A-9B2B-DFEB36D69978}"/>
+              </a:ext>
+            </a:extLst>
+          </p:cNvPr>
+          <p:cNvSpPr txBox="1"/>
+          <p:nvPr/>
+        </p:nvSpPr>
+        <p:spPr>
+          <a:xfrm>
+            <a:off x="457200" y="1682496"/>
+            <a:ext cx="6833616" cy="4524315"/>
+          </a:xfrm>
+          <a:prstGeom prst="rect">
+            <a:avLst/>
+          </a:prstGeom>
+          <a:noFill/>
+        </p:spPr>
+        <p:txBody>
+          <a:bodyPr wrap="square" rtlCol="0">
+            <a:spAutoFit/>
+          </a:bodyPr>
+          <a:lstStyle/>
+          <a:p>
+            <a:r>
+              <a:rPr lang="en-GB" dirty="0" err="1">
+                <a:latin typeface="Helvetica" pitchFamily="2" charset="0"/>
+              </a:rPr>
+              <a:t>Schnittstellen</a:t>
+            </a:r>
+            <a:r>
+              <a:rPr lang="en-GB" dirty="0">
+                <a:latin typeface="Helvetica" pitchFamily="2" charset="0"/>
+              </a:rPr>
+              <a:t>: CSV, </a:t>
+            </a:r>
+            <a:r>
+              <a:rPr lang="en-GB" dirty="0" err="1">
+                <a:latin typeface="Helvetica" pitchFamily="2" charset="0"/>
+              </a:rPr>
+              <a:t>geoJson</a:t>
+            </a:r>
+            <a:endParaRPr lang="en-GB" dirty="0">
+              <a:latin typeface="Helvetica" pitchFamily="2" charset="0"/>
+            </a:endParaRPr>
+          </a:p>
+          <a:p>
+            <a:endParaRPr lang="en-GB" dirty="0">
+              <a:latin typeface="Helvetica" pitchFamily="2" charset="0"/>
+            </a:endParaRPr>
+          </a:p>
+          <a:p>
+            <a:r>
+              <a:rPr lang="en-GB" dirty="0" err="1">
+                <a:latin typeface="Helvetica" pitchFamily="2" charset="0"/>
+              </a:rPr>
+              <a:t>Welche</a:t>
+            </a:r>
+            <a:r>
+              <a:rPr lang="en-GB" dirty="0">
+                <a:latin typeface="Helvetica" pitchFamily="2" charset="0"/>
+              </a:rPr>
+              <a:t> </a:t>
+            </a:r>
+            <a:r>
+              <a:rPr lang="en-GB" dirty="0" err="1">
+                <a:latin typeface="Helvetica" pitchFamily="2" charset="0"/>
+              </a:rPr>
+              <a:t>Daten</a:t>
+            </a:r>
+            <a:r>
+              <a:rPr lang="en-GB" dirty="0">
+                <a:latin typeface="Helvetica" pitchFamily="2" charset="0"/>
+              </a:rPr>
+              <a:t> </a:t>
+            </a:r>
+            <a:r>
+              <a:rPr lang="en-GB" dirty="0" err="1">
+                <a:latin typeface="Helvetica" pitchFamily="2" charset="0"/>
+              </a:rPr>
+              <a:t>könnten</a:t>
+            </a:r>
+            <a:r>
+              <a:rPr lang="en-GB" dirty="0">
+                <a:latin typeface="Helvetica" pitchFamily="2" charset="0"/>
+              </a:rPr>
+              <a:t> </a:t>
+            </a:r>
+            <a:r>
+              <a:rPr lang="en-GB" dirty="0" err="1">
+                <a:latin typeface="Helvetica" pitchFamily="2" charset="0"/>
+              </a:rPr>
+              <a:t>dargstellt</a:t>
+            </a:r>
+            <a:r>
+              <a:rPr lang="en-GB" dirty="0">
+                <a:latin typeface="Helvetica" pitchFamily="2" charset="0"/>
+              </a:rPr>
+              <a:t> </a:t>
+            </a:r>
+            <a:r>
+              <a:rPr lang="en-GB" dirty="0" err="1">
+                <a:latin typeface="Helvetica" pitchFamily="2" charset="0"/>
+              </a:rPr>
+              <a:t>werden</a:t>
+            </a:r>
+            <a:r>
+              <a:rPr lang="en-GB" dirty="0">
+                <a:latin typeface="Helvetica" pitchFamily="2" charset="0"/>
+              </a:rPr>
+              <a:t>?</a:t>
+            </a:r>
+          </a:p>
+          <a:p>
+            <a:pPr marL="285750" indent="-285750">
+              <a:buFontTx/>
+              <a:buChar char="-"/>
+            </a:pPr>
+            <a:r>
+              <a:rPr lang="en-GB" dirty="0">
+                <a:effectLst/>
+                <a:latin typeface="Helvetica" pitchFamily="2" charset="0"/>
+              </a:rPr>
+              <a:t>“live” </a:t>
+            </a:r>
+            <a:r>
+              <a:rPr lang="en-GB" dirty="0" err="1">
+                <a:effectLst/>
+                <a:latin typeface="Helvetica" pitchFamily="2" charset="0"/>
+              </a:rPr>
+              <a:t>Ampel</a:t>
+            </a:r>
+            <a:r>
+              <a:rPr lang="en-GB" dirty="0">
+                <a:effectLst/>
+                <a:latin typeface="Helvetica" pitchFamily="2" charset="0"/>
+              </a:rPr>
+              <a:t> + </a:t>
+            </a:r>
+            <a:r>
+              <a:rPr lang="en-GB" dirty="0" err="1">
+                <a:effectLst/>
+                <a:latin typeface="Helvetica" pitchFamily="2" charset="0"/>
+              </a:rPr>
+              <a:t>Geschwindigkeit</a:t>
+            </a:r>
+            <a:endParaRPr lang="en-GB" dirty="0">
+              <a:effectLst/>
+              <a:latin typeface="Helvetica" pitchFamily="2" charset="0"/>
+            </a:endParaRPr>
+          </a:p>
+          <a:p>
+            <a:pPr marL="285750" indent="-285750">
+              <a:buFontTx/>
+              <a:buChar char="-"/>
+            </a:pPr>
+            <a:r>
+              <a:rPr lang="en-GB" dirty="0" err="1">
+                <a:latin typeface="Helvetica" pitchFamily="2" charset="0"/>
+              </a:rPr>
+              <a:t>Tempolimit</a:t>
+            </a:r>
+            <a:endParaRPr lang="en-GB" dirty="0">
+              <a:latin typeface="Helvetica" pitchFamily="2" charset="0"/>
+            </a:endParaRPr>
+          </a:p>
+          <a:p>
+            <a:pPr marL="285750" indent="-285750">
+              <a:buFontTx/>
+              <a:buChar char="-"/>
+            </a:pPr>
+            <a:r>
+              <a:rPr lang="en-GB" dirty="0" err="1">
+                <a:latin typeface="Helvetica" pitchFamily="2" charset="0"/>
+              </a:rPr>
+              <a:t>Zeitpunkt</a:t>
+            </a:r>
+            <a:r>
+              <a:rPr lang="en-GB" dirty="0">
+                <a:latin typeface="Helvetica" pitchFamily="2" charset="0"/>
+              </a:rPr>
+              <a:t> der </a:t>
+            </a:r>
+            <a:r>
+              <a:rPr lang="en-GB" dirty="0" err="1">
+                <a:latin typeface="Helvetica" pitchFamily="2" charset="0"/>
+              </a:rPr>
+              <a:t>Ampelschaltung</a:t>
+            </a:r>
+            <a:r>
+              <a:rPr lang="en-GB" dirty="0">
+                <a:latin typeface="Helvetica" pitchFamily="2" charset="0"/>
+              </a:rPr>
+              <a:t> </a:t>
+            </a:r>
+          </a:p>
+          <a:p>
+            <a:pPr marL="285750" indent="-285750">
+              <a:buFontTx/>
+              <a:buChar char="-"/>
+            </a:pPr>
+            <a:r>
+              <a:rPr lang="en-GB" dirty="0" err="1">
+                <a:effectLst/>
+                <a:latin typeface="Helvetica" pitchFamily="2" charset="0"/>
+              </a:rPr>
+              <a:t>Geschwin</a:t>
+            </a:r>
+            <a:r>
+              <a:rPr lang="en-GB" dirty="0" err="1">
+                <a:latin typeface="Helvetica" pitchFamily="2" charset="0"/>
+              </a:rPr>
+              <a:t>digkeitsbereich</a:t>
+            </a:r>
+            <a:r>
+              <a:rPr lang="en-GB" dirty="0">
+                <a:latin typeface="Helvetica" pitchFamily="2" charset="0"/>
+              </a:rPr>
+              <a:t>, um </a:t>
+            </a:r>
+            <a:r>
+              <a:rPr lang="en-GB" dirty="0" err="1">
+                <a:latin typeface="Helvetica" pitchFamily="2" charset="0"/>
+              </a:rPr>
+              <a:t>Grün</a:t>
+            </a:r>
+            <a:r>
+              <a:rPr lang="en-GB" dirty="0">
+                <a:latin typeface="Helvetica" pitchFamily="2" charset="0"/>
+              </a:rPr>
+              <a:t> </a:t>
+            </a:r>
+            <a:r>
+              <a:rPr lang="en-GB" dirty="0" err="1">
+                <a:latin typeface="Helvetica" pitchFamily="2" charset="0"/>
+              </a:rPr>
+              <a:t>zu</a:t>
+            </a:r>
+            <a:r>
+              <a:rPr lang="en-GB" dirty="0">
+                <a:latin typeface="Helvetica" pitchFamily="2" charset="0"/>
+              </a:rPr>
+              <a:t> </a:t>
+            </a:r>
+            <a:r>
+              <a:rPr lang="en-GB" dirty="0" err="1">
+                <a:latin typeface="Helvetica" pitchFamily="2" charset="0"/>
+              </a:rPr>
+              <a:t>erreichen</a:t>
+            </a:r>
+            <a:endParaRPr lang="en-GB" dirty="0">
+              <a:latin typeface="Helvetica" pitchFamily="2" charset="0"/>
+            </a:endParaRPr>
+          </a:p>
+          <a:p>
+            <a:endParaRPr lang="en-GB" dirty="0">
+              <a:effectLst/>
+              <a:latin typeface="Helvetica" pitchFamily="2" charset="0"/>
+            </a:endParaRPr>
+          </a:p>
+          <a:p>
+            <a:pPr marL="285750" indent="-285750">
+              <a:buFontTx/>
+              <a:buChar char="-"/>
+            </a:pPr>
+            <a:r>
+              <a:rPr lang="en-GB" dirty="0" err="1">
+                <a:latin typeface="Helvetica" pitchFamily="2" charset="0"/>
+              </a:rPr>
+              <a:t>Routenplanung</a:t>
+            </a:r>
+            <a:r>
+              <a:rPr lang="en-GB" dirty="0">
+                <a:latin typeface="Helvetica" pitchFamily="2" charset="0"/>
+              </a:rPr>
+              <a:t>: </a:t>
+            </a:r>
+            <a:r>
+              <a:rPr lang="en-GB" dirty="0" err="1">
+                <a:latin typeface="Helvetica" pitchFamily="2" charset="0"/>
+              </a:rPr>
+              <a:t>Fahre</a:t>
+            </a:r>
+            <a:r>
+              <a:rPr lang="en-GB" dirty="0">
+                <a:latin typeface="Helvetica" pitchFamily="2" charset="0"/>
+              </a:rPr>
+              <a:t> </a:t>
+            </a:r>
+            <a:r>
+              <a:rPr lang="en-GB" dirty="0" err="1">
+                <a:latin typeface="Helvetica" pitchFamily="2" charset="0"/>
+              </a:rPr>
+              <a:t>danach</a:t>
+            </a:r>
+            <a:r>
+              <a:rPr lang="en-GB" dirty="0">
+                <a:latin typeface="Helvetica" pitchFamily="2" charset="0"/>
+              </a:rPr>
+              <a:t> ... </a:t>
+            </a:r>
+          </a:p>
+          <a:p>
+            <a:endParaRPr lang="en-GB" dirty="0">
+              <a:effectLst/>
+              <a:latin typeface="Helvetica" pitchFamily="2" charset="0"/>
+            </a:endParaRPr>
+          </a:p>
+          <a:p>
+            <a:r>
+              <a:rPr lang="en-GB" dirty="0">
+                <a:latin typeface="Helvetica" pitchFamily="2" charset="0"/>
+              </a:rPr>
+              <a:t>- </a:t>
+            </a:r>
+            <a:r>
+              <a:rPr lang="en-GB" dirty="0" err="1">
+                <a:latin typeface="Helvetica" pitchFamily="2" charset="0"/>
+              </a:rPr>
+              <a:t>grober</a:t>
+            </a:r>
+            <a:r>
+              <a:rPr lang="en-GB" dirty="0">
+                <a:latin typeface="Helvetica" pitchFamily="2" charset="0"/>
+              </a:rPr>
+              <a:t> </a:t>
+            </a:r>
+            <a:r>
+              <a:rPr lang="en-GB" dirty="0" err="1">
+                <a:latin typeface="Helvetica" pitchFamily="2" charset="0"/>
+              </a:rPr>
+              <a:t>Fortschritt</a:t>
+            </a:r>
+            <a:r>
+              <a:rPr lang="en-GB" dirty="0">
+                <a:latin typeface="Helvetica" pitchFamily="2" charset="0"/>
+              </a:rPr>
+              <a:t> </a:t>
+            </a:r>
+            <a:r>
+              <a:rPr lang="en-GB" dirty="0" err="1">
+                <a:latin typeface="Helvetica" pitchFamily="2" charset="0"/>
+              </a:rPr>
+              <a:t>zur</a:t>
+            </a:r>
+            <a:r>
+              <a:rPr lang="en-GB" dirty="0">
+                <a:latin typeface="Helvetica" pitchFamily="2" charset="0"/>
+              </a:rPr>
+              <a:t> </a:t>
+            </a:r>
+            <a:r>
+              <a:rPr lang="en-GB" dirty="0" err="1">
+                <a:latin typeface="Helvetica" pitchFamily="2" charset="0"/>
+              </a:rPr>
+              <a:t>Ampel</a:t>
+            </a:r>
+            <a:endParaRPr lang="en-GB" dirty="0">
+              <a:effectLst/>
+              <a:latin typeface="Helvetica" pitchFamily="2" charset="0"/>
+            </a:endParaRPr>
+          </a:p>
+          <a:p>
+            <a:pPr marL="285750" indent="-285750">
+              <a:buFontTx/>
+              <a:buChar char="-"/>
+            </a:pPr>
+            <a:endParaRPr lang="en-GB" dirty="0">
+              <a:effectLst/>
+              <a:latin typeface="Helvetica" pitchFamily="2" charset="0"/>
+            </a:endParaRPr>
+          </a:p>
+          <a:p>
+            <a:r>
+              <a:rPr lang="en-GB" dirty="0" err="1">
+                <a:effectLst/>
+                <a:latin typeface="Helvetica" pitchFamily="2" charset="0"/>
+              </a:rPr>
+              <a:t>Welche</a:t>
+            </a:r>
+            <a:r>
+              <a:rPr lang="en-GB" dirty="0">
+                <a:effectLst/>
+                <a:latin typeface="Helvetica" pitchFamily="2" charset="0"/>
+              </a:rPr>
+              <a:t> </a:t>
+            </a:r>
+            <a:r>
+              <a:rPr lang="en-GB" dirty="0" err="1">
+                <a:effectLst/>
+                <a:latin typeface="Helvetica" pitchFamily="2" charset="0"/>
+              </a:rPr>
+              <a:t>Daten</a:t>
+            </a:r>
+            <a:r>
+              <a:rPr lang="en-GB" dirty="0">
+                <a:effectLst/>
+                <a:latin typeface="Helvetica" pitchFamily="2" charset="0"/>
+              </a:rPr>
+              <a:t> </a:t>
+            </a:r>
+            <a:r>
+              <a:rPr lang="en-GB" dirty="0" err="1">
+                <a:effectLst/>
+                <a:latin typeface="Helvetica" pitchFamily="2" charset="0"/>
+              </a:rPr>
+              <a:t>könnten</a:t>
+            </a:r>
+            <a:r>
+              <a:rPr lang="en-GB" dirty="0">
+                <a:effectLst/>
+                <a:latin typeface="Helvetica" pitchFamily="2" charset="0"/>
+              </a:rPr>
+              <a:t> </a:t>
+            </a:r>
+            <a:r>
+              <a:rPr lang="en-GB" dirty="0" err="1">
+                <a:effectLst/>
+                <a:latin typeface="Helvetica" pitchFamily="2" charset="0"/>
+              </a:rPr>
+              <a:t>visualisiert</a:t>
+            </a:r>
+            <a:r>
+              <a:rPr lang="en-GB" dirty="0">
+                <a:effectLst/>
+                <a:latin typeface="Helvetica" pitchFamily="2" charset="0"/>
+              </a:rPr>
+              <a:t> </a:t>
+            </a:r>
+            <a:r>
+              <a:rPr lang="en-GB" dirty="0" err="1">
+                <a:effectLst/>
+                <a:latin typeface="Helvetica" pitchFamily="2" charset="0"/>
+              </a:rPr>
+              <a:t>werden</a:t>
+            </a:r>
+            <a:r>
+              <a:rPr lang="en-GB" dirty="0">
+                <a:effectLst/>
+                <a:latin typeface="Helvetica" pitchFamily="2" charset="0"/>
+              </a:rPr>
+              <a:t>?</a:t>
+            </a:r>
+          </a:p>
+          <a:p>
+            <a:pPr marL="285750" indent="-285750">
+              <a:buFontTx/>
+              <a:buChar char="-"/>
+            </a:pPr>
+            <a:r>
+              <a:rPr lang="en-GB" dirty="0" err="1">
+                <a:latin typeface="Helvetica" pitchFamily="2" charset="0"/>
+              </a:rPr>
+              <a:t>Standort</a:t>
+            </a:r>
+            <a:endParaRPr lang="en-GB" dirty="0">
+              <a:latin typeface="Helvetica" pitchFamily="2" charset="0"/>
+            </a:endParaRPr>
+          </a:p>
+          <a:p>
+            <a:pPr marL="285750" indent="-285750">
+              <a:buFontTx/>
+              <a:buChar char="-"/>
+            </a:pPr>
+            <a:r>
+              <a:rPr lang="en-GB" dirty="0" err="1">
+                <a:effectLst/>
+                <a:latin typeface="Helvetica" pitchFamily="2" charset="0"/>
+              </a:rPr>
+              <a:t>Pfad</a:t>
+            </a:r>
+            <a:endParaRPr lang="en-GB" dirty="0">
+              <a:effectLst/>
+              <a:latin typeface="Helvetica" pitchFamily="2" charset="0"/>
+            </a:endParaRPr>
+          </a:p>
+          <a:p>
+            <a:pPr marL="285750" indent="-285750">
+              <a:buFontTx/>
+              <a:buChar char="-"/>
+            </a:pPr>
+            <a:r>
+              <a:rPr lang="en-GB" dirty="0" err="1">
+                <a:latin typeface="Helvetica" pitchFamily="2" charset="0"/>
+              </a:rPr>
+              <a:t>Ampeln</a:t>
+            </a:r>
+            <a:endParaRPr lang="en-GB" dirty="0">
+              <a:effectLst/>
+              <a:latin typeface="Helvetica" pitchFamily="2" charset="0"/>
+            </a:endParaRPr>
+          </a:p>
+        </p:txBody>
+      </p:sp>
+    </p:spTree>
+    <p:extLst>
+      <p:ext uri="{BB962C8B-B14F-4D97-AF65-F5344CB8AC3E}">
+        <p14:creationId xmlns:p14="http://schemas.microsoft.com/office/powerpoint/2010/main" val="2504474160"/>
       </p:ext>
     </p:extLst>
   </p:cSld>
@@ -9660,7 +10250,7 @@
           <a:p>
             <a:fld id="{67FB260B-9787-2941-BD6E-E8B8AEB1B5A8}" type="datetime1">
               <a:rPr lang="de-DE" smtClean="0"/>
-              <a:t>21.10.2024</a:t>
+              <a:t>22.10.24</a:t>
             </a:fld>
             <a:endParaRPr lang="en-DE" dirty="0"/>
           </a:p>
@@ -9916,7 +10506,7 @@
           <a:p>
             <a:fld id="{0FBC0988-905C-AB41-86EF-B70567269C0A}" type="datetime1">
               <a:rPr lang="de-DE" smtClean="0"/>
-              <a:t>21.10.2024</a:t>
+              <a:t>22.10.24</a:t>
             </a:fld>
             <a:endParaRPr lang="en-DE" dirty="0"/>
           </a:p>
@@ -10986,7 +11576,7 @@
           <a:p>
             <a:fld id="{0FBC0988-905C-AB41-86EF-B70567269C0A}" type="datetime1">
               <a:rPr lang="de-DE" smtClean="0"/>
-              <a:t>21.10.2024</a:t>
+              <a:t>22.10.24</a:t>
             </a:fld>
             <a:endParaRPr lang="en-DE" dirty="0"/>
           </a:p>
@@ -11243,7 +11833,7 @@
           <a:p>
             <a:fld id="{0FBC0988-905C-AB41-86EF-B70567269C0A}" type="datetime1">
               <a:rPr lang="de-DE" smtClean="0"/>
-              <a:t>21.10.2024</a:t>
+              <a:t>22.10.24</a:t>
             </a:fld>
             <a:endParaRPr lang="en-DE" dirty="0"/>
           </a:p>
@@ -11599,7 +12189,7 @@
           <a:p>
             <a:fld id="{0FBC0988-905C-AB41-86EF-B70567269C0A}" type="datetime1">
               <a:rPr lang="de-DE" smtClean="0"/>
-              <a:t>21.10.2024</a:t>
+              <a:t>22.10.24</a:t>
             </a:fld>
             <a:endParaRPr lang="en-DE" dirty="0"/>
           </a:p>
@@ -11715,7 +12305,7 @@
           <a:p>
             <a:fld id="{12798F19-8D51-794B-8ACF-FCEE93C20526}" type="datetime1">
               <a:rPr lang="de-DE" smtClean="0"/>
-              <a:t>21.10.2024</a:t>
+              <a:t>22.10.24</a:t>
             </a:fld>
             <a:endParaRPr lang="en-DE"/>
           </a:p>
@@ -12050,7 +12640,7 @@
           <a:p>
             <a:fld id="{12798F19-8D51-794B-8ACF-FCEE93C20526}" type="datetime1">
               <a:rPr lang="de-DE" smtClean="0"/>
-              <a:t>21.10.2024</a:t>
+              <a:t>22.10.24</a:t>
             </a:fld>
             <a:endParaRPr lang="en-DE"/>
           </a:p>
@@ -12242,7 +12832,7 @@
           <a:p>
             <a:fld id="{12798F19-8D51-794B-8ACF-FCEE93C20526}" type="datetime1">
               <a:rPr lang="de-DE" smtClean="0"/>
-              <a:t>21.10.2024</a:t>
+              <a:t>22.10.24</a:t>
             </a:fld>
             <a:endParaRPr lang="en-DE"/>
           </a:p>

</xml_diff>